<commit_message>
Silhouette score calculated an all cluster's models
</commit_message>
<xml_diff>
--- a/poster1.pptx
+++ b/poster1.pptx
@@ -4,6 +4,9 @@
   <p:sldMasterIdLst>
     <p:sldMasterId id="2147483684" r:id="rId1"/>
   </p:sldMasterIdLst>
+  <p:notesMasterIdLst>
+    <p:notesMasterId r:id="rId3"/>
+  </p:notesMasterIdLst>
   <p:sldIdLst>
     <p:sldId id="256" r:id="rId2"/>
   </p:sldIdLst>
@@ -112,6 +115,439 @@
 </p:presentation>
 </file>
 
+<file path=ppt/notesMasters/notesMaster1.xml><?xml version="1.0" encoding="utf-8"?>
+<p:notesMaster xmlns:a="http://schemas.openxmlformats.org/drawingml/2006/main" xmlns:r="http://schemas.openxmlformats.org/officeDocument/2006/relationships" xmlns:p="http://schemas.openxmlformats.org/presentationml/2006/main">
+  <p:cSld>
+    <p:bg>
+      <p:bgRef idx="1001">
+        <a:schemeClr val="bg1"/>
+      </p:bgRef>
+    </p:bg>
+    <p:spTree>
+      <p:nvGrpSpPr>
+        <p:cNvPr id="1" name=""/>
+        <p:cNvGrpSpPr/>
+        <p:nvPr/>
+      </p:nvGrpSpPr>
+      <p:grpSpPr>
+        <a:xfrm>
+          <a:off x="0" y="0"/>
+          <a:ext cx="0" cy="0"/>
+          <a:chOff x="0" y="0"/>
+          <a:chExt cx="0" cy="0"/>
+        </a:xfrm>
+      </p:grpSpPr>
+      <p:sp>
+        <p:nvSpPr>
+          <p:cNvPr id="2" name="Header Placeholder 1"/>
+          <p:cNvSpPr>
+            <a:spLocks noGrp="1"/>
+          </p:cNvSpPr>
+          <p:nvPr>
+            <p:ph type="hdr" sz="quarter"/>
+          </p:nvPr>
+        </p:nvSpPr>
+        <p:spPr>
+          <a:xfrm>
+            <a:off x="0" y="0"/>
+            <a:ext cx="2971800" cy="458788"/>
+          </a:xfrm>
+          <a:prstGeom prst="rect">
+            <a:avLst/>
+          </a:prstGeom>
+        </p:spPr>
+        <p:txBody>
+          <a:bodyPr vert="horz" lIns="91440" tIns="45720" rIns="91440" bIns="45720" rtlCol="0"/>
+          <a:lstStyle>
+            <a:lvl1pPr algn="l">
+              <a:defRPr sz="1200"/>
+            </a:lvl1pPr>
+          </a:lstStyle>
+          <a:p>
+            <a:endParaRPr lang="en-US"/>
+          </a:p>
+        </p:txBody>
+      </p:sp>
+      <p:sp>
+        <p:nvSpPr>
+          <p:cNvPr id="3" name="Date Placeholder 2"/>
+          <p:cNvSpPr>
+            <a:spLocks noGrp="1"/>
+          </p:cNvSpPr>
+          <p:nvPr>
+            <p:ph type="dt" idx="1"/>
+          </p:nvPr>
+        </p:nvSpPr>
+        <p:spPr>
+          <a:xfrm>
+            <a:off x="3884613" y="0"/>
+            <a:ext cx="2971800" cy="458788"/>
+          </a:xfrm>
+          <a:prstGeom prst="rect">
+            <a:avLst/>
+          </a:prstGeom>
+        </p:spPr>
+        <p:txBody>
+          <a:bodyPr vert="horz" lIns="91440" tIns="45720" rIns="91440" bIns="45720" rtlCol="0"/>
+          <a:lstStyle>
+            <a:lvl1pPr algn="r">
+              <a:defRPr sz="1200"/>
+            </a:lvl1pPr>
+          </a:lstStyle>
+          <a:p>
+            <a:fld id="{852A926C-90D6-4289-8F51-DD29ED19146F}" type="datetimeFigureOut">
+              <a:rPr lang="en-US" smtClean="0"/>
+              <a:t>10/21/2026</a:t>
+            </a:fld>
+            <a:endParaRPr lang="en-US"/>
+          </a:p>
+        </p:txBody>
+      </p:sp>
+      <p:sp>
+        <p:nvSpPr>
+          <p:cNvPr id="4" name="Slide Image Placeholder 3"/>
+          <p:cNvSpPr>
+            <a:spLocks noGrp="1" noRot="1" noChangeAspect="1"/>
+          </p:cNvSpPr>
+          <p:nvPr>
+            <p:ph type="sldImg" idx="2"/>
+          </p:nvPr>
+        </p:nvSpPr>
+        <p:spPr>
+          <a:xfrm>
+            <a:off x="1371600" y="1143000"/>
+            <a:ext cx="4114800" cy="3086100"/>
+          </a:xfrm>
+          <a:prstGeom prst="rect">
+            <a:avLst/>
+          </a:prstGeom>
+          <a:noFill/>
+          <a:ln w="12700">
+            <a:solidFill>
+              <a:prstClr val="black"/>
+            </a:solidFill>
+          </a:ln>
+        </p:spPr>
+        <p:txBody>
+          <a:bodyPr vert="horz" lIns="91440" tIns="45720" rIns="91440" bIns="45720" rtlCol="0" anchor="ctr"/>
+          <a:lstStyle/>
+          <a:p>
+            <a:endParaRPr lang="en-US"/>
+          </a:p>
+        </p:txBody>
+      </p:sp>
+      <p:sp>
+        <p:nvSpPr>
+          <p:cNvPr id="5" name="Notes Placeholder 4"/>
+          <p:cNvSpPr>
+            <a:spLocks noGrp="1"/>
+          </p:cNvSpPr>
+          <p:nvPr>
+            <p:ph type="body" sz="quarter" idx="3"/>
+          </p:nvPr>
+        </p:nvSpPr>
+        <p:spPr>
+          <a:xfrm>
+            <a:off x="685800" y="4400550"/>
+            <a:ext cx="5486400" cy="3600450"/>
+          </a:xfrm>
+          <a:prstGeom prst="rect">
+            <a:avLst/>
+          </a:prstGeom>
+        </p:spPr>
+        <p:txBody>
+          <a:bodyPr vert="horz" lIns="91440" tIns="45720" rIns="91440" bIns="45720" rtlCol="0"/>
+          <a:lstStyle/>
+          <a:p>
+            <a:pPr lvl="0"/>
+            <a:r>
+              <a:rPr lang="en-US"/>
+              <a:t>Click to edit Master text styles</a:t>
+            </a:r>
+          </a:p>
+          <a:p>
+            <a:pPr lvl="1"/>
+            <a:r>
+              <a:rPr lang="en-US"/>
+              <a:t>Second level</a:t>
+            </a:r>
+          </a:p>
+          <a:p>
+            <a:pPr lvl="2"/>
+            <a:r>
+              <a:rPr lang="en-US"/>
+              <a:t>Third level</a:t>
+            </a:r>
+          </a:p>
+          <a:p>
+            <a:pPr lvl="3"/>
+            <a:r>
+              <a:rPr lang="en-US"/>
+              <a:t>Fourth level</a:t>
+            </a:r>
+          </a:p>
+          <a:p>
+            <a:pPr lvl="4"/>
+            <a:r>
+              <a:rPr lang="en-US"/>
+              <a:t>Fifth level</a:t>
+            </a:r>
+          </a:p>
+        </p:txBody>
+      </p:sp>
+      <p:sp>
+        <p:nvSpPr>
+          <p:cNvPr id="6" name="Footer Placeholder 5"/>
+          <p:cNvSpPr>
+            <a:spLocks noGrp="1"/>
+          </p:cNvSpPr>
+          <p:nvPr>
+            <p:ph type="ftr" sz="quarter" idx="4"/>
+          </p:nvPr>
+        </p:nvSpPr>
+        <p:spPr>
+          <a:xfrm>
+            <a:off x="0" y="8685213"/>
+            <a:ext cx="2971800" cy="458787"/>
+          </a:xfrm>
+          <a:prstGeom prst="rect">
+            <a:avLst/>
+          </a:prstGeom>
+        </p:spPr>
+        <p:txBody>
+          <a:bodyPr vert="horz" lIns="91440" tIns="45720" rIns="91440" bIns="45720" rtlCol="0" anchor="b"/>
+          <a:lstStyle>
+            <a:lvl1pPr algn="l">
+              <a:defRPr sz="1200"/>
+            </a:lvl1pPr>
+          </a:lstStyle>
+          <a:p>
+            <a:endParaRPr lang="en-US"/>
+          </a:p>
+        </p:txBody>
+      </p:sp>
+      <p:sp>
+        <p:nvSpPr>
+          <p:cNvPr id="7" name="Slide Number Placeholder 6"/>
+          <p:cNvSpPr>
+            <a:spLocks noGrp="1"/>
+          </p:cNvSpPr>
+          <p:nvPr>
+            <p:ph type="sldNum" sz="quarter" idx="5"/>
+          </p:nvPr>
+        </p:nvSpPr>
+        <p:spPr>
+          <a:xfrm>
+            <a:off x="3884613" y="8685213"/>
+            <a:ext cx="2971800" cy="458787"/>
+          </a:xfrm>
+          <a:prstGeom prst="rect">
+            <a:avLst/>
+          </a:prstGeom>
+        </p:spPr>
+        <p:txBody>
+          <a:bodyPr vert="horz" lIns="91440" tIns="45720" rIns="91440" bIns="45720" rtlCol="0" anchor="b"/>
+          <a:lstStyle>
+            <a:lvl1pPr algn="r">
+              <a:defRPr sz="1200"/>
+            </a:lvl1pPr>
+          </a:lstStyle>
+          <a:p>
+            <a:fld id="{4E147058-A90E-4E07-B0EE-B5AA252222B8}" type="slidenum">
+              <a:rPr lang="en-US" smtClean="0"/>
+              <a:t>‹#›</a:t>
+            </a:fld>
+            <a:endParaRPr lang="en-US"/>
+          </a:p>
+        </p:txBody>
+      </p:sp>
+    </p:spTree>
+    <p:extLst>
+      <p:ext uri="{BB962C8B-B14F-4D97-AF65-F5344CB8AC3E}">
+        <p14:creationId xmlns:p14="http://schemas.microsoft.com/office/powerpoint/2010/main" val="456960262"/>
+      </p:ext>
+    </p:extLst>
+  </p:cSld>
+  <p:clrMap bg1="lt1" tx1="dk1" bg2="lt2" tx2="dk2" accent1="accent1" accent2="accent2" accent3="accent3" accent4="accent4" accent5="accent5" accent6="accent6" hlink="hlink" folHlink="folHlink"/>
+  <p:notesStyle>
+    <a:lvl1pPr marL="0" algn="l" defTabSz="914400" rtl="0" eaLnBrk="1" latinLnBrk="0" hangingPunct="1">
+      <a:defRPr sz="1200" kern="1200">
+        <a:solidFill>
+          <a:schemeClr val="tx1"/>
+        </a:solidFill>
+        <a:latin typeface="+mn-lt"/>
+        <a:ea typeface="+mn-ea"/>
+        <a:cs typeface="+mn-cs"/>
+      </a:defRPr>
+    </a:lvl1pPr>
+    <a:lvl2pPr marL="457200" algn="l" defTabSz="914400" rtl="0" eaLnBrk="1" latinLnBrk="0" hangingPunct="1">
+      <a:defRPr sz="1200" kern="1200">
+        <a:solidFill>
+          <a:schemeClr val="tx1"/>
+        </a:solidFill>
+        <a:latin typeface="+mn-lt"/>
+        <a:ea typeface="+mn-ea"/>
+        <a:cs typeface="+mn-cs"/>
+      </a:defRPr>
+    </a:lvl2pPr>
+    <a:lvl3pPr marL="914400" algn="l" defTabSz="914400" rtl="0" eaLnBrk="1" latinLnBrk="0" hangingPunct="1">
+      <a:defRPr sz="1200" kern="1200">
+        <a:solidFill>
+          <a:schemeClr val="tx1"/>
+        </a:solidFill>
+        <a:latin typeface="+mn-lt"/>
+        <a:ea typeface="+mn-ea"/>
+        <a:cs typeface="+mn-cs"/>
+      </a:defRPr>
+    </a:lvl3pPr>
+    <a:lvl4pPr marL="1371600" algn="l" defTabSz="914400" rtl="0" eaLnBrk="1" latinLnBrk="0" hangingPunct="1">
+      <a:defRPr sz="1200" kern="1200">
+        <a:solidFill>
+          <a:schemeClr val="tx1"/>
+        </a:solidFill>
+        <a:latin typeface="+mn-lt"/>
+        <a:ea typeface="+mn-ea"/>
+        <a:cs typeface="+mn-cs"/>
+      </a:defRPr>
+    </a:lvl4pPr>
+    <a:lvl5pPr marL="1828800" algn="l" defTabSz="914400" rtl="0" eaLnBrk="1" latinLnBrk="0" hangingPunct="1">
+      <a:defRPr sz="1200" kern="1200">
+        <a:solidFill>
+          <a:schemeClr val="tx1"/>
+        </a:solidFill>
+        <a:latin typeface="+mn-lt"/>
+        <a:ea typeface="+mn-ea"/>
+        <a:cs typeface="+mn-cs"/>
+      </a:defRPr>
+    </a:lvl5pPr>
+    <a:lvl6pPr marL="2286000" algn="l" defTabSz="914400" rtl="0" eaLnBrk="1" latinLnBrk="0" hangingPunct="1">
+      <a:defRPr sz="1200" kern="1200">
+        <a:solidFill>
+          <a:schemeClr val="tx1"/>
+        </a:solidFill>
+        <a:latin typeface="+mn-lt"/>
+        <a:ea typeface="+mn-ea"/>
+        <a:cs typeface="+mn-cs"/>
+      </a:defRPr>
+    </a:lvl6pPr>
+    <a:lvl7pPr marL="2743200" algn="l" defTabSz="914400" rtl="0" eaLnBrk="1" latinLnBrk="0" hangingPunct="1">
+      <a:defRPr sz="1200" kern="1200">
+        <a:solidFill>
+          <a:schemeClr val="tx1"/>
+        </a:solidFill>
+        <a:latin typeface="+mn-lt"/>
+        <a:ea typeface="+mn-ea"/>
+        <a:cs typeface="+mn-cs"/>
+      </a:defRPr>
+    </a:lvl7pPr>
+    <a:lvl8pPr marL="3200400" algn="l" defTabSz="914400" rtl="0" eaLnBrk="1" latinLnBrk="0" hangingPunct="1">
+      <a:defRPr sz="1200" kern="1200">
+        <a:solidFill>
+          <a:schemeClr val="tx1"/>
+        </a:solidFill>
+        <a:latin typeface="+mn-lt"/>
+        <a:ea typeface="+mn-ea"/>
+        <a:cs typeface="+mn-cs"/>
+      </a:defRPr>
+    </a:lvl8pPr>
+    <a:lvl9pPr marL="3657600" algn="l" defTabSz="914400" rtl="0" eaLnBrk="1" latinLnBrk="0" hangingPunct="1">
+      <a:defRPr sz="1200" kern="1200">
+        <a:solidFill>
+          <a:schemeClr val="tx1"/>
+        </a:solidFill>
+        <a:latin typeface="+mn-lt"/>
+        <a:ea typeface="+mn-ea"/>
+        <a:cs typeface="+mn-cs"/>
+      </a:defRPr>
+    </a:lvl9pPr>
+  </p:notesStyle>
+</p:notesMaster>
+</file>
+
+<file path=ppt/notesSlides/notesSlide1.xml><?xml version="1.0" encoding="utf-8"?>
+<p:notes xmlns:a="http://schemas.openxmlformats.org/drawingml/2006/main" xmlns:r="http://schemas.openxmlformats.org/officeDocument/2006/relationships" xmlns:p="http://schemas.openxmlformats.org/presentationml/2006/main">
+  <p:cSld>
+    <p:spTree>
+      <p:nvGrpSpPr>
+        <p:cNvPr id="1" name=""/>
+        <p:cNvGrpSpPr/>
+        <p:nvPr/>
+      </p:nvGrpSpPr>
+      <p:grpSpPr>
+        <a:xfrm>
+          <a:off x="0" y="0"/>
+          <a:ext cx="0" cy="0"/>
+          <a:chOff x="0" y="0"/>
+          <a:chExt cx="0" cy="0"/>
+        </a:xfrm>
+      </p:grpSpPr>
+      <p:sp>
+        <p:nvSpPr>
+          <p:cNvPr id="2" name="Slide Image Placeholder 1"/>
+          <p:cNvSpPr>
+            <a:spLocks noGrp="1" noRot="1" noChangeAspect="1"/>
+          </p:cNvSpPr>
+          <p:nvPr>
+            <p:ph type="sldImg"/>
+          </p:nvPr>
+        </p:nvSpPr>
+        <p:spPr/>
+      </p:sp>
+      <p:sp>
+        <p:nvSpPr>
+          <p:cNvPr id="3" name="Notes Placeholder 2"/>
+          <p:cNvSpPr>
+            <a:spLocks noGrp="1"/>
+          </p:cNvSpPr>
+          <p:nvPr>
+            <p:ph type="body" idx="1"/>
+          </p:nvPr>
+        </p:nvSpPr>
+        <p:spPr/>
+        <p:txBody>
+          <a:bodyPr/>
+          <a:lstStyle/>
+          <a:p>
+            <a:endParaRPr lang="en-US" dirty="0"/>
+          </a:p>
+        </p:txBody>
+      </p:sp>
+      <p:sp>
+        <p:nvSpPr>
+          <p:cNvPr id="4" name="Slide Number Placeholder 3"/>
+          <p:cNvSpPr>
+            <a:spLocks noGrp="1"/>
+          </p:cNvSpPr>
+          <p:nvPr>
+            <p:ph type="sldNum" sz="quarter" idx="5"/>
+          </p:nvPr>
+        </p:nvSpPr>
+        <p:spPr/>
+        <p:txBody>
+          <a:bodyPr/>
+          <a:lstStyle/>
+          <a:p>
+            <a:fld id="{4E147058-A90E-4E07-B0EE-B5AA252222B8}" type="slidenum">
+              <a:rPr lang="en-US" smtClean="0"/>
+              <a:t>1</a:t>
+            </a:fld>
+            <a:endParaRPr lang="en-US"/>
+          </a:p>
+        </p:txBody>
+      </p:sp>
+    </p:spTree>
+    <p:extLst>
+      <p:ext uri="{BB962C8B-B14F-4D97-AF65-F5344CB8AC3E}">
+        <p14:creationId xmlns:p14="http://schemas.microsoft.com/office/powerpoint/2010/main" val="732770969"/>
+      </p:ext>
+    </p:extLst>
+  </p:cSld>
+  <p:clrMapOvr>
+    <a:masterClrMapping/>
+  </p:clrMapOvr>
+</p:notes>
+</file>
+
 <file path=ppt/slideLayouts/slideLayout1.xml><?xml version="1.0" encoding="utf-8"?>
 <p:sldLayout xmlns:a="http://schemas.openxmlformats.org/drawingml/2006/main" xmlns:r="http://schemas.openxmlformats.org/officeDocument/2006/relationships" xmlns:p="http://schemas.openxmlformats.org/presentationml/2006/main" type="title" preserve="1">
   <p:cSld name="Title Slide">
@@ -243,7 +679,7 @@
           <a:p>
             <a:fld id="{BACA1C7C-A57E-4601-A266-C84919E8106A}" type="datetimeFigureOut">
               <a:rPr lang="en-US" smtClean="0"/>
-              <a:t>10/12/2026</a:t>
+              <a:t>10/21/2026</a:t>
             </a:fld>
             <a:endParaRPr lang="en-US"/>
           </a:p>
@@ -413,7 +849,7 @@
           <a:p>
             <a:fld id="{BACA1C7C-A57E-4601-A266-C84919E8106A}" type="datetimeFigureOut">
               <a:rPr lang="en-US" smtClean="0"/>
-              <a:t>10/12/2026</a:t>
+              <a:t>10/21/2026</a:t>
             </a:fld>
             <a:endParaRPr lang="en-US"/>
           </a:p>
@@ -593,7 +1029,7 @@
           <a:p>
             <a:fld id="{BACA1C7C-A57E-4601-A266-C84919E8106A}" type="datetimeFigureOut">
               <a:rPr lang="en-US" smtClean="0"/>
-              <a:t>10/12/2026</a:t>
+              <a:t>10/21/2026</a:t>
             </a:fld>
             <a:endParaRPr lang="en-US"/>
           </a:p>
@@ -763,7 +1199,7 @@
           <a:p>
             <a:fld id="{BACA1C7C-A57E-4601-A266-C84919E8106A}" type="datetimeFigureOut">
               <a:rPr lang="en-US" smtClean="0"/>
-              <a:t>10/12/2026</a:t>
+              <a:t>10/21/2026</a:t>
             </a:fld>
             <a:endParaRPr lang="en-US"/>
           </a:p>
@@ -1007,7 +1443,7 @@
           <a:p>
             <a:fld id="{BACA1C7C-A57E-4601-A266-C84919E8106A}" type="datetimeFigureOut">
               <a:rPr lang="en-US" smtClean="0"/>
-              <a:t>10/12/2026</a:t>
+              <a:t>10/21/2026</a:t>
             </a:fld>
             <a:endParaRPr lang="en-US"/>
           </a:p>
@@ -1239,7 +1675,7 @@
           <a:p>
             <a:fld id="{BACA1C7C-A57E-4601-A266-C84919E8106A}" type="datetimeFigureOut">
               <a:rPr lang="en-US" smtClean="0"/>
-              <a:t>10/12/2026</a:t>
+              <a:t>10/21/2026</a:t>
             </a:fld>
             <a:endParaRPr lang="en-US"/>
           </a:p>
@@ -1606,7 +2042,7 @@
           <a:p>
             <a:fld id="{BACA1C7C-A57E-4601-A266-C84919E8106A}" type="datetimeFigureOut">
               <a:rPr lang="en-US" smtClean="0"/>
-              <a:t>10/12/2026</a:t>
+              <a:t>10/21/2026</a:t>
             </a:fld>
             <a:endParaRPr lang="en-US"/>
           </a:p>
@@ -1724,7 +2160,7 @@
           <a:p>
             <a:fld id="{BACA1C7C-A57E-4601-A266-C84919E8106A}" type="datetimeFigureOut">
               <a:rPr lang="en-US" smtClean="0"/>
-              <a:t>10/12/2026</a:t>
+              <a:t>10/21/2026</a:t>
             </a:fld>
             <a:endParaRPr lang="en-US"/>
           </a:p>
@@ -1819,7 +2255,7 @@
           <a:p>
             <a:fld id="{BACA1C7C-A57E-4601-A266-C84919E8106A}" type="datetimeFigureOut">
               <a:rPr lang="en-US" smtClean="0"/>
-              <a:t>10/12/2026</a:t>
+              <a:t>10/21/2026</a:t>
             </a:fld>
             <a:endParaRPr lang="en-US"/>
           </a:p>
@@ -2096,7 +2532,7 @@
           <a:p>
             <a:fld id="{BACA1C7C-A57E-4601-A266-C84919E8106A}" type="datetimeFigureOut">
               <a:rPr lang="en-US" smtClean="0"/>
-              <a:t>10/12/2026</a:t>
+              <a:t>10/21/2026</a:t>
             </a:fld>
             <a:endParaRPr lang="en-US"/>
           </a:p>
@@ -2349,7 +2785,7 @@
           <a:p>
             <a:fld id="{BACA1C7C-A57E-4601-A266-C84919E8106A}" type="datetimeFigureOut">
               <a:rPr lang="en-US" smtClean="0"/>
-              <a:t>10/12/2026</a:t>
+              <a:t>10/21/2026</a:t>
             </a:fld>
             <a:endParaRPr lang="en-US"/>
           </a:p>
@@ -2562,7 +2998,7 @@
           <a:p>
             <a:fld id="{BACA1C7C-A57E-4601-A266-C84919E8106A}" type="datetimeFigureOut">
               <a:rPr lang="en-US" smtClean="0"/>
-              <a:t>10/12/2026</a:t>
+              <a:t>10/21/2026</a:t>
             </a:fld>
             <a:endParaRPr lang="en-US"/>
           </a:p>
@@ -2992,14 +3428,28 @@
         </p:nvSpPr>
         <p:spPr>
           <a:xfrm>
-            <a:off x="1318610" y="1982413"/>
-            <a:ext cx="12092590" cy="9233297"/>
+            <a:off x="992476" y="2681382"/>
+            <a:ext cx="41906248" cy="2400657"/>
           </a:xfrm>
           <a:prstGeom prst="rect">
             <a:avLst/>
           </a:prstGeom>
-          <a:noFill/>
+          <a:ln/>
         </p:spPr>
+        <p:style>
+          <a:lnRef idx="2">
+            <a:schemeClr val="accent2"/>
+          </a:lnRef>
+          <a:fillRef idx="1">
+            <a:schemeClr val="lt1"/>
+          </a:fillRef>
+          <a:effectRef idx="0">
+            <a:schemeClr val="accent2"/>
+          </a:effectRef>
+          <a:fontRef idx="minor">
+            <a:schemeClr val="dk1"/>
+          </a:fontRef>
+        </p:style>
         <p:txBody>
           <a:bodyPr wrap="square" rtlCol="0">
             <a:spAutoFit/>
@@ -3008,197 +3458,52 @@
           <a:p>
             <a:pPr algn="just"/>
             <a:r>
-              <a:rPr lang="en-US" sz="3600" dirty="0">
+              <a:rPr lang="en-US" sz="3200" b="1" dirty="0">
+                <a:solidFill>
+                  <a:schemeClr val="tx1"/>
+                </a:solidFill>
                 <a:latin typeface="Arial" panose="020B0604020202020204" pitchFamily="34" charset="0"/>
                 <a:cs typeface="Arial" panose="020B0604020202020204" pitchFamily="34" charset="0"/>
               </a:rPr>
-              <a:t>Data has been collected from UC Irvine and originally has 2.07 million rows and 9 columns.</a:t>
-            </a:r>
-          </a:p>
-          <a:p>
-            <a:pPr algn="just"/>
-            <a:r>
-              <a:rPr lang="en-US" sz="3600" dirty="0">
+              <a:t>INTRODUCTION</a:t>
+            </a:r>
+            <a:endParaRPr lang="en-US" sz="3200" dirty="0">
+              <a:solidFill>
+                <a:schemeClr val="tx1"/>
+              </a:solidFill>
+              <a:latin typeface="Arial" panose="020B0604020202020204" pitchFamily="34" charset="0"/>
+              <a:cs typeface="Arial" panose="020B0604020202020204" pitchFamily="34" charset="0"/>
+            </a:endParaRPr>
+          </a:p>
+          <a:p>
+            <a:pPr algn="just"/>
+            <a:r>
+              <a:rPr lang="en-US" sz="3200" dirty="0">
+                <a:solidFill>
+                  <a:schemeClr val="tx1"/>
+                </a:solidFill>
                 <a:latin typeface="Arial" panose="020B0604020202020204" pitchFamily="34" charset="0"/>
                 <a:cs typeface="Arial" panose="020B0604020202020204" pitchFamily="34" charset="0"/>
               </a:rPr>
-              <a:t>Measuremets of electric power consumption in just one household with a one minute sampling rate over a period in Dec.2006 to Nov.2010. It shows different electrical quantities and some sub-metering values which kitchen stuffs, laundry room and water heater and air conditioner. This data represents household electricity consumption by one household usage so it will be include housing data category. But the data uploaded has 1.04 million rows, 9 columns for two years due to computer did not have enough raw. In the future, results will be based on the uploaded data.</a:t>
-            </a:r>
-          </a:p>
-          <a:p>
-            <a:pPr algn="just"/>
-            <a:r>
-              <a:rPr lang="en-US" sz="3600" dirty="0">
-                <a:latin typeface="Arial" panose="020B0604020202020204" pitchFamily="34" charset="0"/>
-                <a:cs typeface="Arial" panose="020B0604020202020204" pitchFamily="34" charset="0"/>
-              </a:rPr>
-              <a:t>Household electricity consumption patterns have been identified by clusters, and electricity consumption is projected to increase until 2028 by time series model.  </a:t>
-            </a:r>
-          </a:p>
-          <a:p>
-            <a:endParaRPr lang="en-US" dirty="0"/>
-          </a:p>
-        </p:txBody>
-      </p:sp>
-      <p:sp>
-        <p:nvSpPr>
-          <p:cNvPr id="6" name="TextBox 5">
-            <a:extLst>
-              <a:ext uri="{FF2B5EF4-FFF2-40B4-BE49-F238E27FC236}">
-                <a16:creationId xmlns:a16="http://schemas.microsoft.com/office/drawing/2014/main" id="{1E5B043E-F281-0978-1A7D-D75DC444ABFE}"/>
-              </a:ext>
-            </a:extLst>
-          </p:cNvPr>
-          <p:cNvSpPr txBox="1"/>
-          <p:nvPr/>
-        </p:nvSpPr>
-        <p:spPr>
-          <a:xfrm>
-            <a:off x="1318608" y="11029574"/>
-            <a:ext cx="12092590" cy="7140416"/>
-          </a:xfrm>
-          <a:prstGeom prst="rect">
-            <a:avLst/>
-          </a:prstGeom>
-          <a:noFill/>
-        </p:spPr>
-        <p:txBody>
-          <a:bodyPr wrap="square" rtlCol="0">
-            <a:spAutoFit/>
-          </a:bodyPr>
-          <a:lstStyle/>
-          <a:p>
-            <a:pPr algn="just"/>
-            <a:r>
-              <a:rPr lang="en-US" sz="4000" b="1" dirty="0">
-                <a:latin typeface="Arial" panose="020B0604020202020204" pitchFamily="34" charset="0"/>
-                <a:cs typeface="Arial" panose="020B0604020202020204" pitchFamily="34" charset="0"/>
-              </a:rPr>
-              <a:t>METHOD</a:t>
-            </a:r>
-          </a:p>
-          <a:p>
-            <a:pPr algn="just"/>
-            <a:r>
-              <a:rPr lang="en-US" sz="3600" dirty="0">
-                <a:latin typeface="Arial" panose="020B0604020202020204" pitchFamily="34" charset="0"/>
-                <a:cs typeface="Arial" panose="020B0604020202020204" pitchFamily="34" charset="0"/>
-              </a:rPr>
-              <a:t>Missing values have been filled with the median. Data includes every single minute of electricity consumption, so it has been converted into four categories Morning, Afternoon, Evening, and Night. And I used </a:t>
-            </a:r>
-            <a:r>
-              <a:rPr lang="en-US" sz="3600" dirty="0" err="1">
-                <a:latin typeface="Arial" panose="020B0604020202020204" pitchFamily="34" charset="0"/>
-                <a:cs typeface="Arial" panose="020B0604020202020204" pitchFamily="34" charset="0"/>
-              </a:rPr>
-              <a:t>StandardScaler</a:t>
-            </a:r>
-            <a:r>
-              <a:rPr lang="en-US" sz="3600" dirty="0">
-                <a:latin typeface="Arial" panose="020B0604020202020204" pitchFamily="34" charset="0"/>
-                <a:cs typeface="Arial" panose="020B0604020202020204" pitchFamily="34" charset="0"/>
-              </a:rPr>
-              <a:t> because the data was in different units and had different variables. Used 4 clustering models which K-means, K-</a:t>
-            </a:r>
-            <a:r>
-              <a:rPr lang="en-US" sz="3600" dirty="0" err="1">
-                <a:latin typeface="Arial" panose="020B0604020202020204" pitchFamily="34" charset="0"/>
-                <a:cs typeface="Arial" panose="020B0604020202020204" pitchFamily="34" charset="0"/>
-              </a:rPr>
-              <a:t>meidod</a:t>
-            </a:r>
-            <a:r>
-              <a:rPr lang="en-US" sz="3600" dirty="0">
-                <a:latin typeface="Arial" panose="020B0604020202020204" pitchFamily="34" charset="0"/>
-                <a:cs typeface="Arial" panose="020B0604020202020204" pitchFamily="34" charset="0"/>
-              </a:rPr>
-              <a:t>, DSCCAN, FUZZYC-</a:t>
-            </a:r>
-            <a:r>
-              <a:rPr lang="en-US" sz="3600" dirty="0" err="1">
-                <a:latin typeface="Arial" panose="020B0604020202020204" pitchFamily="34" charset="0"/>
-                <a:cs typeface="Arial" panose="020B0604020202020204" pitchFamily="34" charset="0"/>
-              </a:rPr>
-              <a:t>menas</a:t>
-            </a:r>
-            <a:r>
-              <a:rPr lang="en-US" sz="3600" dirty="0">
-                <a:latin typeface="Arial" panose="020B0604020202020204" pitchFamily="34" charset="0"/>
-                <a:cs typeface="Arial" panose="020B0604020202020204" pitchFamily="34" charset="0"/>
-              </a:rPr>
-              <a:t> and SARIMA , Holt-Winters Exponential Smoothing for Time Series. </a:t>
-            </a:r>
-          </a:p>
-          <a:p>
-            <a:pPr algn="just"/>
-            <a:endParaRPr lang="en-US" sz="4400" dirty="0">
-              <a:latin typeface="Arial" panose="020B0604020202020204" pitchFamily="34" charset="0"/>
-              <a:cs typeface="Arial" panose="020B0604020202020204" pitchFamily="34" charset="0"/>
-            </a:endParaRPr>
-          </a:p>
-          <a:p>
-            <a:endParaRPr lang="en-US" sz="5400" dirty="0">
-              <a:latin typeface="Arial" panose="020B0604020202020204" pitchFamily="34" charset="0"/>
-              <a:cs typeface="Arial" panose="020B0604020202020204" pitchFamily="34" charset="0"/>
-            </a:endParaRPr>
-          </a:p>
-          <a:p>
-            <a:endParaRPr lang="en-US" dirty="0"/>
-          </a:p>
-        </p:txBody>
-      </p:sp>
-      <p:sp>
-        <p:nvSpPr>
-          <p:cNvPr id="11" name="TextBox 10">
-            <a:extLst>
-              <a:ext uri="{FF2B5EF4-FFF2-40B4-BE49-F238E27FC236}">
-                <a16:creationId xmlns:a16="http://schemas.microsoft.com/office/drawing/2014/main" id="{BEBB7CD1-7C60-106E-4903-8727E166C437}"/>
-              </a:ext>
-            </a:extLst>
-          </p:cNvPr>
-          <p:cNvSpPr txBox="1"/>
-          <p:nvPr/>
-        </p:nvSpPr>
-        <p:spPr>
-          <a:xfrm>
-            <a:off x="1318608" y="16095459"/>
-            <a:ext cx="12843162" cy="2554545"/>
-          </a:xfrm>
-          <a:prstGeom prst="rect">
-            <a:avLst/>
-          </a:prstGeom>
-          <a:noFill/>
-        </p:spPr>
-        <p:txBody>
-          <a:bodyPr wrap="square" rtlCol="0">
-            <a:spAutoFit/>
-          </a:bodyPr>
-          <a:lstStyle/>
-          <a:p>
-            <a:pPr algn="just"/>
-            <a:r>
-              <a:rPr lang="en-US" sz="4000" b="1" dirty="0">
-                <a:latin typeface="Arial" panose="020B0604020202020204" pitchFamily="34" charset="0"/>
-                <a:cs typeface="Arial" panose="020B0604020202020204" pitchFamily="34" charset="0"/>
-              </a:rPr>
-              <a:t>DESCRIBE STATISTICS AND GRAPHS</a:t>
-            </a:r>
-          </a:p>
-          <a:p>
-            <a:pPr algn="just"/>
-            <a:endParaRPr lang="en-US" sz="4400" dirty="0">
-              <a:latin typeface="Arial" panose="020B0604020202020204" pitchFamily="34" charset="0"/>
-              <a:cs typeface="Arial" panose="020B0604020202020204" pitchFamily="34" charset="0"/>
-            </a:endParaRPr>
-          </a:p>
-          <a:p>
-            <a:endParaRPr lang="en-US" sz="5400" dirty="0">
-              <a:latin typeface="Arial" panose="020B0604020202020204" pitchFamily="34" charset="0"/>
-              <a:cs typeface="Arial" panose="020B0604020202020204" pitchFamily="34" charset="0"/>
-            </a:endParaRPr>
-          </a:p>
-          <a:p>
-            <a:endParaRPr lang="en-US" dirty="0"/>
+              <a:t>Data is 1.04 million rows, 9 columns, between Dec.2006 to Nov.2027. Measurements of electric power consumption in just one household with a one-minute sampling rate over a period. It shows different electrical quantities and some sub-metering values. This data represents household electricity consumption by one household usage so it will be include housing data category. </a:t>
+            </a:r>
+          </a:p>
+          <a:p>
+            <a:pPr algn="just"/>
+            <a:endParaRPr lang="en-US" sz="3600" dirty="0">
+              <a:solidFill>
+                <a:srgbClr val="FF0000"/>
+              </a:solidFill>
+              <a:latin typeface="Arial" panose="020B0604020202020204" pitchFamily="34" charset="0"/>
+              <a:cs typeface="Arial" panose="020B0604020202020204" pitchFamily="34" charset="0"/>
+            </a:endParaRPr>
+          </a:p>
+          <a:p>
+            <a:endParaRPr lang="en-US" dirty="0">
+              <a:solidFill>
+                <a:schemeClr val="bg1"/>
+              </a:solidFill>
+            </a:endParaRPr>
           </a:p>
         </p:txBody>
       </p:sp>
@@ -3216,7 +3521,7 @@
         </p:nvSpPr>
         <p:spPr>
           <a:xfrm>
-            <a:off x="15610612" y="997528"/>
+            <a:off x="5092815" y="5194050"/>
             <a:ext cx="12843162" cy="984885"/>
           </a:xfrm>
           <a:prstGeom prst="rect">
@@ -3257,7 +3562,7 @@
         </p:nvSpPr>
         <p:spPr>
           <a:xfrm>
-            <a:off x="30123938" y="956652"/>
+            <a:off x="27297261" y="5117514"/>
             <a:ext cx="12843162" cy="707886"/>
           </a:xfrm>
           <a:prstGeom prst="rect">
@@ -3295,14 +3600,28 @@
         </p:nvSpPr>
         <p:spPr>
           <a:xfrm>
-            <a:off x="15524019" y="1982413"/>
-            <a:ext cx="12487101" cy="32408872"/>
+            <a:off x="992477" y="5984188"/>
+            <a:ext cx="20528280" cy="20199096"/>
           </a:xfrm>
           <a:prstGeom prst="rect">
             <a:avLst/>
           </a:prstGeom>
-          <a:noFill/>
+          <a:ln/>
         </p:spPr>
+        <p:style>
+          <a:lnRef idx="2">
+            <a:schemeClr val="accent2"/>
+          </a:lnRef>
+          <a:fillRef idx="1">
+            <a:schemeClr val="lt1"/>
+          </a:fillRef>
+          <a:effectRef idx="0">
+            <a:schemeClr val="accent2"/>
+          </a:effectRef>
+          <a:fontRef idx="minor">
+            <a:schemeClr val="dk1"/>
+          </a:fontRef>
+        </p:style>
         <p:txBody>
           <a:bodyPr wrap="square" rtlCol="0">
             <a:spAutoFit/>
@@ -3311,240 +3630,301 @@
           <a:p>
             <a:pPr algn="just"/>
             <a:r>
-              <a:rPr lang="en-US" sz="3600" b="1" dirty="0">
+              <a:rPr lang="en-US" sz="3200" b="1" dirty="0">
+                <a:solidFill>
+                  <a:schemeClr val="tx1"/>
+                </a:solidFill>
                 <a:latin typeface="Arial" panose="020B0604020202020204" pitchFamily="34" charset="0"/>
                 <a:cs typeface="Arial" panose="020B0604020202020204" pitchFamily="34" charset="0"/>
               </a:rPr>
-              <a:t>K-means</a:t>
-            </a:r>
-            <a:endParaRPr lang="en-US" sz="4800" b="1" dirty="0">
-              <a:latin typeface="Arial" panose="020B0604020202020204" pitchFamily="34" charset="0"/>
-              <a:cs typeface="Arial" panose="020B0604020202020204" pitchFamily="34" charset="0"/>
-            </a:endParaRPr>
-          </a:p>
-          <a:p>
-            <a:pPr algn="just"/>
-            <a:r>
-              <a:rPr lang="en-US" sz="4800" dirty="0">
-                <a:latin typeface="Arial" panose="020B0604020202020204" pitchFamily="34" charset="0"/>
-                <a:cs typeface="Arial" panose="020B0604020202020204" pitchFamily="34" charset="0"/>
-              </a:rPr>
-              <a:t>	</a:t>
-            </a:r>
-            <a:r>
-              <a:rPr lang="en-US" sz="3600" dirty="0">
-                <a:latin typeface="Arial" panose="020B0604020202020204" pitchFamily="34" charset="0"/>
-                <a:cs typeface="Arial" panose="020B0604020202020204" pitchFamily="34" charset="0"/>
-              </a:rPr>
-              <a:t>Data has been clustered into 4 groups. Household electricity consumption in the morning and at night is higher than in the afternoon and evening, with even more usage during that time average power consumption is 2.5 to 3.4. In despite of Afternoon usage reaching to lowest level. During the evening, average power consumption is 0.8. </a:t>
-            </a:r>
-          </a:p>
-          <a:p>
-            <a:pPr algn="just"/>
-            <a:r>
-              <a:rPr lang="en-US" sz="4800" dirty="0">
-                <a:latin typeface="Arial" panose="020B0604020202020204" pitchFamily="34" charset="0"/>
-                <a:cs typeface="Arial" panose="020B0604020202020204" pitchFamily="34" charset="0"/>
-              </a:rPr>
-              <a:t>																								</a:t>
-            </a:r>
-          </a:p>
-          <a:p>
-            <a:pPr algn="just"/>
-            <a:endParaRPr lang="en-US" sz="4800" dirty="0">
-              <a:latin typeface="Arial" panose="020B0604020202020204" pitchFamily="34" charset="0"/>
-              <a:cs typeface="Arial" panose="020B0604020202020204" pitchFamily="34" charset="0"/>
-            </a:endParaRPr>
-          </a:p>
-          <a:p>
-            <a:pPr algn="just"/>
-            <a:endParaRPr lang="en-US" sz="4800" dirty="0">
-              <a:latin typeface="Arial" panose="020B0604020202020204" pitchFamily="34" charset="0"/>
-              <a:cs typeface="Arial" panose="020B0604020202020204" pitchFamily="34" charset="0"/>
-            </a:endParaRPr>
-          </a:p>
-          <a:p>
-            <a:pPr algn="just"/>
-            <a:endParaRPr lang="en-US" sz="4800" dirty="0">
-              <a:latin typeface="Arial" panose="020B0604020202020204" pitchFamily="34" charset="0"/>
-              <a:cs typeface="Arial" panose="020B0604020202020204" pitchFamily="34" charset="0"/>
-            </a:endParaRPr>
-          </a:p>
-          <a:p>
-            <a:pPr algn="just"/>
-            <a:endParaRPr lang="en-US" sz="4800" dirty="0">
-              <a:latin typeface="Arial" panose="020B0604020202020204" pitchFamily="34" charset="0"/>
-              <a:cs typeface="Arial" panose="020B0604020202020204" pitchFamily="34" charset="0"/>
-            </a:endParaRPr>
-          </a:p>
-          <a:p>
-            <a:pPr algn="just"/>
-            <a:r>
-              <a:rPr lang="en-US" sz="3600" dirty="0">
-                <a:latin typeface="Arial" panose="020B0604020202020204" pitchFamily="34" charset="0"/>
-                <a:cs typeface="Arial" panose="020B0604020202020204" pitchFamily="34" charset="0"/>
-              </a:rPr>
-              <a:t>The elbow method and Silhouette score were used to determine how many clusters suit the data. The elbow mothed showed optimal cluster number is 4. The Silhouette score showed that 3 clusters will predict better, at 42 percent. </a:t>
-            </a:r>
-          </a:p>
-          <a:p>
-            <a:pPr algn="just"/>
-            <a:r>
-              <a:rPr lang="en-US" sz="3600" b="1" dirty="0">
+              <a:t>K-Means</a:t>
+            </a:r>
+          </a:p>
+          <a:p>
+            <a:pPr algn="just"/>
+            <a:endParaRPr lang="en-US" sz="3200" b="1" dirty="0">
+              <a:latin typeface="Arial" panose="020B0604020202020204" pitchFamily="34" charset="0"/>
+              <a:cs typeface="Arial" panose="020B0604020202020204" pitchFamily="34" charset="0"/>
+            </a:endParaRPr>
+          </a:p>
+          <a:p>
+            <a:pPr algn="just"/>
+            <a:endParaRPr lang="en-US" sz="3200" b="1" dirty="0">
+              <a:latin typeface="Arial" panose="020B0604020202020204" pitchFamily="34" charset="0"/>
+              <a:cs typeface="Arial" panose="020B0604020202020204" pitchFamily="34" charset="0"/>
+            </a:endParaRPr>
+          </a:p>
+          <a:p>
+            <a:pPr algn="just"/>
+            <a:endParaRPr lang="en-US" sz="3200" b="1" dirty="0">
+              <a:latin typeface="Arial" panose="020B0604020202020204" pitchFamily="34" charset="0"/>
+              <a:cs typeface="Arial" panose="020B0604020202020204" pitchFamily="34" charset="0"/>
+            </a:endParaRPr>
+          </a:p>
+          <a:p>
+            <a:pPr algn="just"/>
+            <a:endParaRPr lang="en-US" sz="3200" b="1" dirty="0">
+              <a:latin typeface="Arial" panose="020B0604020202020204" pitchFamily="34" charset="0"/>
+              <a:cs typeface="Arial" panose="020B0604020202020204" pitchFamily="34" charset="0"/>
+            </a:endParaRPr>
+          </a:p>
+          <a:p>
+            <a:pPr algn="just"/>
+            <a:endParaRPr lang="en-US" sz="3200" b="1" dirty="0">
+              <a:latin typeface="Arial" panose="020B0604020202020204" pitchFamily="34" charset="0"/>
+              <a:cs typeface="Arial" panose="020B0604020202020204" pitchFamily="34" charset="0"/>
+            </a:endParaRPr>
+          </a:p>
+          <a:p>
+            <a:pPr algn="just"/>
+            <a:endParaRPr lang="en-US" sz="3200" b="1" dirty="0">
+              <a:latin typeface="Arial" panose="020B0604020202020204" pitchFamily="34" charset="0"/>
+              <a:cs typeface="Arial" panose="020B0604020202020204" pitchFamily="34" charset="0"/>
+            </a:endParaRPr>
+          </a:p>
+          <a:p>
+            <a:pPr algn="just"/>
+            <a:endParaRPr lang="en-US" sz="3200" b="1" dirty="0">
+              <a:latin typeface="Arial" panose="020B0604020202020204" pitchFamily="34" charset="0"/>
+              <a:cs typeface="Arial" panose="020B0604020202020204" pitchFamily="34" charset="0"/>
+            </a:endParaRPr>
+          </a:p>
+          <a:p>
+            <a:pPr algn="just"/>
+            <a:endParaRPr lang="en-US" sz="3200" b="1" dirty="0">
+              <a:latin typeface="Arial" panose="020B0604020202020204" pitchFamily="34" charset="0"/>
+              <a:cs typeface="Arial" panose="020B0604020202020204" pitchFamily="34" charset="0"/>
+            </a:endParaRPr>
+          </a:p>
+          <a:p>
+            <a:pPr algn="just"/>
+            <a:endParaRPr lang="en-US" sz="3200" b="1" dirty="0">
+              <a:solidFill>
+                <a:schemeClr val="tx1"/>
+              </a:solidFill>
+              <a:latin typeface="Arial" panose="020B0604020202020204" pitchFamily="34" charset="0"/>
+              <a:cs typeface="Arial" panose="020B0604020202020204" pitchFamily="34" charset="0"/>
+            </a:endParaRPr>
+          </a:p>
+          <a:p>
+            <a:pPr algn="just"/>
+            <a:r>
+              <a:rPr lang="en-US" sz="3200" b="1" dirty="0">
+                <a:solidFill>
+                  <a:schemeClr val="tx1"/>
+                </a:solidFill>
                 <a:latin typeface="Arial" panose="020B0604020202020204" pitchFamily="34" charset="0"/>
                 <a:cs typeface="Arial" panose="020B0604020202020204" pitchFamily="34" charset="0"/>
               </a:rPr>
               <a:t>K-</a:t>
             </a:r>
             <a:r>
-              <a:rPr lang="en-US" sz="3600" b="1" dirty="0" err="1">
+              <a:rPr lang="en-US" sz="3200" b="1" dirty="0" err="1">
+                <a:solidFill>
+                  <a:schemeClr val="tx1"/>
+                </a:solidFill>
                 <a:latin typeface="Arial" panose="020B0604020202020204" pitchFamily="34" charset="0"/>
                 <a:cs typeface="Arial" panose="020B0604020202020204" pitchFamily="34" charset="0"/>
               </a:rPr>
               <a:t>Meidod</a:t>
             </a:r>
-            <a:endParaRPr lang="en-US" sz="3600" b="1" dirty="0">
-              <a:latin typeface="Arial" panose="020B0604020202020204" pitchFamily="34" charset="0"/>
-              <a:cs typeface="Arial" panose="020B0604020202020204" pitchFamily="34" charset="0"/>
-            </a:endParaRPr>
-          </a:p>
-          <a:p>
-            <a:pPr algn="just"/>
-            <a:r>
-              <a:rPr lang="en-US" sz="3600" dirty="0">
+            <a:endParaRPr lang="en-US" sz="3200" b="1" dirty="0">
+              <a:solidFill>
+                <a:schemeClr val="tx1"/>
+              </a:solidFill>
+              <a:latin typeface="Arial" panose="020B0604020202020204" pitchFamily="34" charset="0"/>
+              <a:cs typeface="Arial" panose="020B0604020202020204" pitchFamily="34" charset="0"/>
+            </a:endParaRPr>
+          </a:p>
+          <a:p>
+            <a:pPr algn="just"/>
+            <a:endParaRPr lang="en-US" sz="3200" dirty="0">
+              <a:latin typeface="Arial" panose="020B0604020202020204" pitchFamily="34" charset="0"/>
+              <a:cs typeface="Arial" panose="020B0604020202020204" pitchFamily="34" charset="0"/>
+            </a:endParaRPr>
+          </a:p>
+          <a:p>
+            <a:pPr algn="just"/>
+            <a:endParaRPr lang="en-US" sz="3200" dirty="0">
+              <a:latin typeface="Arial" panose="020B0604020202020204" pitchFamily="34" charset="0"/>
+              <a:cs typeface="Arial" panose="020B0604020202020204" pitchFamily="34" charset="0"/>
+            </a:endParaRPr>
+          </a:p>
+          <a:p>
+            <a:pPr algn="just"/>
+            <a:endParaRPr lang="en-US" sz="3200" dirty="0">
+              <a:latin typeface="Arial" panose="020B0604020202020204" pitchFamily="34" charset="0"/>
+              <a:cs typeface="Arial" panose="020B0604020202020204" pitchFamily="34" charset="0"/>
+            </a:endParaRPr>
+          </a:p>
+          <a:p>
+            <a:pPr algn="just"/>
+            <a:endParaRPr lang="en-US" sz="3200" dirty="0">
+              <a:latin typeface="Arial" panose="020B0604020202020204" pitchFamily="34" charset="0"/>
+              <a:cs typeface="Arial" panose="020B0604020202020204" pitchFamily="34" charset="0"/>
+            </a:endParaRPr>
+          </a:p>
+          <a:p>
+            <a:pPr algn="just"/>
+            <a:endParaRPr lang="en-US" sz="3200" dirty="0">
+              <a:latin typeface="Arial" panose="020B0604020202020204" pitchFamily="34" charset="0"/>
+              <a:cs typeface="Arial" panose="020B0604020202020204" pitchFamily="34" charset="0"/>
+            </a:endParaRPr>
+          </a:p>
+          <a:p>
+            <a:pPr algn="just"/>
+            <a:endParaRPr lang="en-US" sz="3200" dirty="0">
+              <a:latin typeface="Arial" panose="020B0604020202020204" pitchFamily="34" charset="0"/>
+              <a:cs typeface="Arial" panose="020B0604020202020204" pitchFamily="34" charset="0"/>
+            </a:endParaRPr>
+          </a:p>
+          <a:p>
+            <a:pPr algn="just"/>
+            <a:endParaRPr lang="en-US" sz="3200" dirty="0">
+              <a:latin typeface="Arial" panose="020B0604020202020204" pitchFamily="34" charset="0"/>
+              <a:cs typeface="Arial" panose="020B0604020202020204" pitchFamily="34" charset="0"/>
+            </a:endParaRPr>
+          </a:p>
+          <a:p>
+            <a:pPr algn="just"/>
+            <a:endParaRPr lang="en-US" sz="3200" b="1" dirty="0">
+              <a:latin typeface="Arial" panose="020B0604020202020204" pitchFamily="34" charset="0"/>
+              <a:cs typeface="Arial" panose="020B0604020202020204" pitchFamily="34" charset="0"/>
+            </a:endParaRPr>
+          </a:p>
+          <a:p>
+            <a:pPr algn="just"/>
+            <a:endParaRPr lang="en-US" sz="3200" b="1" dirty="0">
+              <a:solidFill>
+                <a:schemeClr val="tx1"/>
+              </a:solidFill>
+              <a:latin typeface="Arial" panose="020B0604020202020204" pitchFamily="34" charset="0"/>
+              <a:cs typeface="Arial" panose="020B0604020202020204" pitchFamily="34" charset="0"/>
+            </a:endParaRPr>
+          </a:p>
+          <a:p>
+            <a:pPr algn="just"/>
+            <a:r>
+              <a:rPr lang="en-US" sz="3200" b="1" dirty="0">
+                <a:solidFill>
+                  <a:schemeClr val="tx1"/>
+                </a:solidFill>
                 <a:latin typeface="Arial" panose="020B0604020202020204" pitchFamily="34" charset="0"/>
                 <a:cs typeface="Arial" panose="020B0604020202020204" pitchFamily="34" charset="0"/>
               </a:rPr>
-              <a:t>Data has clustered into four categories, where nighttime electricity consumption is low, and morning and evening are significantly increased. </a:t>
-            </a:r>
-          </a:p>
-          <a:p>
-            <a:pPr algn="just"/>
-            <a:r>
-              <a:rPr lang="en-US" sz="3600" b="1" dirty="0">
+              <a:t>DBSCAN </a:t>
+            </a:r>
+          </a:p>
+          <a:p>
+            <a:pPr algn="just"/>
+            <a:endParaRPr lang="en-US" sz="3200" b="1" dirty="0">
+              <a:latin typeface="Arial" panose="020B0604020202020204" pitchFamily="34" charset="0"/>
+              <a:cs typeface="Arial" panose="020B0604020202020204" pitchFamily="34" charset="0"/>
+            </a:endParaRPr>
+          </a:p>
+          <a:p>
+            <a:pPr algn="just"/>
+            <a:endParaRPr lang="en-US" sz="3200" b="1" dirty="0">
+              <a:latin typeface="Arial" panose="020B0604020202020204" pitchFamily="34" charset="0"/>
+              <a:cs typeface="Arial" panose="020B0604020202020204" pitchFamily="34" charset="0"/>
+            </a:endParaRPr>
+          </a:p>
+          <a:p>
+            <a:pPr algn="just"/>
+            <a:endParaRPr lang="en-US" sz="3200" b="1" dirty="0">
+              <a:latin typeface="Arial" panose="020B0604020202020204" pitchFamily="34" charset="0"/>
+              <a:cs typeface="Arial" panose="020B0604020202020204" pitchFamily="34" charset="0"/>
+            </a:endParaRPr>
+          </a:p>
+          <a:p>
+            <a:pPr algn="just"/>
+            <a:endParaRPr lang="en-US" sz="3200" b="1" dirty="0">
+              <a:latin typeface="Arial" panose="020B0604020202020204" pitchFamily="34" charset="0"/>
+              <a:cs typeface="Arial" panose="020B0604020202020204" pitchFamily="34" charset="0"/>
+            </a:endParaRPr>
+          </a:p>
+          <a:p>
+            <a:pPr algn="just"/>
+            <a:endParaRPr lang="en-US" sz="3200" b="1" dirty="0">
+              <a:latin typeface="Arial" panose="020B0604020202020204" pitchFamily="34" charset="0"/>
+              <a:cs typeface="Arial" panose="020B0604020202020204" pitchFamily="34" charset="0"/>
+            </a:endParaRPr>
+          </a:p>
+          <a:p>
+            <a:pPr algn="just"/>
+            <a:endParaRPr lang="en-US" sz="3200" b="1" dirty="0">
+              <a:latin typeface="Arial" panose="020B0604020202020204" pitchFamily="34" charset="0"/>
+              <a:cs typeface="Arial" panose="020B0604020202020204" pitchFamily="34" charset="0"/>
+            </a:endParaRPr>
+          </a:p>
+          <a:p>
+            <a:pPr algn="just"/>
+            <a:endParaRPr lang="en-US" sz="3200" b="1" dirty="0">
+              <a:latin typeface="Arial" panose="020B0604020202020204" pitchFamily="34" charset="0"/>
+              <a:cs typeface="Arial" panose="020B0604020202020204" pitchFamily="34" charset="0"/>
+            </a:endParaRPr>
+          </a:p>
+          <a:p>
+            <a:pPr algn="just"/>
+            <a:endParaRPr lang="en-US" sz="3200" b="1" dirty="0">
+              <a:latin typeface="Arial" panose="020B0604020202020204" pitchFamily="34" charset="0"/>
+              <a:cs typeface="Arial" panose="020B0604020202020204" pitchFamily="34" charset="0"/>
+            </a:endParaRPr>
+          </a:p>
+          <a:p>
+            <a:pPr algn="just"/>
+            <a:endParaRPr lang="en-US" sz="3200" b="1" dirty="0">
+              <a:solidFill>
+                <a:schemeClr val="bg1"/>
+              </a:solidFill>
+              <a:latin typeface="Arial" panose="020B0604020202020204" pitchFamily="34" charset="0"/>
+              <a:cs typeface="Arial" panose="020B0604020202020204" pitchFamily="34" charset="0"/>
+            </a:endParaRPr>
+          </a:p>
+          <a:p>
+            <a:pPr algn="just"/>
+            <a:r>
+              <a:rPr lang="en-US" sz="3200" b="1" dirty="0">
+                <a:solidFill>
+                  <a:schemeClr val="tx1"/>
+                </a:solidFill>
                 <a:latin typeface="Arial" panose="020B0604020202020204" pitchFamily="34" charset="0"/>
                 <a:cs typeface="Arial" panose="020B0604020202020204" pitchFamily="34" charset="0"/>
               </a:rPr>
-              <a:t>DBSCAN</a:t>
-            </a:r>
-            <a:r>
-              <a:rPr lang="en-US" sz="4800" b="1" dirty="0">
-                <a:latin typeface="Arial" panose="020B0604020202020204" pitchFamily="34" charset="0"/>
-                <a:cs typeface="Arial" panose="020B0604020202020204" pitchFamily="34" charset="0"/>
-              </a:rPr>
-              <a:t> </a:t>
-            </a:r>
-          </a:p>
-          <a:p>
-            <a:pPr algn="just"/>
-            <a:r>
-              <a:rPr lang="en-US" sz="3600" dirty="0">
-                <a:latin typeface="Arial" panose="020B0604020202020204" pitchFamily="34" charset="0"/>
-                <a:cs typeface="Arial" panose="020B0604020202020204" pitchFamily="34" charset="0"/>
-              </a:rPr>
-              <a:t>Maximum K-distance is 0.4, min points are 6. In case, optimal labels has three </a:t>
-            </a:r>
-            <a:r>
-              <a:rPr lang="en-US" sz="3600" dirty="0" err="1">
-                <a:latin typeface="Arial" panose="020B0604020202020204" pitchFamily="34" charset="0"/>
-                <a:cs typeface="Arial" panose="020B0604020202020204" pitchFamily="34" charset="0"/>
-              </a:rPr>
-              <a:t>categoriesories</a:t>
-            </a:r>
-            <a:r>
-              <a:rPr lang="en-US" sz="3600" dirty="0">
-                <a:latin typeface="Arial" panose="020B0604020202020204" pitchFamily="34" charset="0"/>
-                <a:cs typeface="Arial" panose="020B0604020202020204" pitchFamily="34" charset="0"/>
-              </a:rPr>
-              <a:t> which 0 is 963, minus 1 is 30, 1 is 7. Household electricity consumption is usually lower. In some cases, when accidentally using high electricity around 4 to 4.5, the voltage is dropped to a normal level. About 30 is model-identified random usage.</a:t>
-            </a:r>
-          </a:p>
-          <a:p>
-            <a:pPr algn="just"/>
-            <a:endParaRPr lang="en-US" sz="3600" dirty="0">
-              <a:latin typeface="Arial" panose="020B0604020202020204" pitchFamily="34" charset="0"/>
-              <a:cs typeface="Arial" panose="020B0604020202020204" pitchFamily="34" charset="0"/>
-            </a:endParaRPr>
-          </a:p>
-          <a:p>
-            <a:pPr algn="just"/>
-            <a:endParaRPr lang="en-US" sz="3600" dirty="0">
-              <a:latin typeface="Arial" panose="020B0604020202020204" pitchFamily="34" charset="0"/>
-              <a:cs typeface="Arial" panose="020B0604020202020204" pitchFamily="34" charset="0"/>
-            </a:endParaRPr>
-          </a:p>
-          <a:p>
-            <a:pPr algn="just"/>
-            <a:endParaRPr lang="en-US" sz="3600" dirty="0">
-              <a:latin typeface="Arial" panose="020B0604020202020204" pitchFamily="34" charset="0"/>
-              <a:cs typeface="Arial" panose="020B0604020202020204" pitchFamily="34" charset="0"/>
-            </a:endParaRPr>
-          </a:p>
-          <a:p>
-            <a:pPr algn="just"/>
-            <a:endParaRPr lang="en-US" sz="3600" dirty="0">
-              <a:latin typeface="Arial" panose="020B0604020202020204" pitchFamily="34" charset="0"/>
-              <a:cs typeface="Arial" panose="020B0604020202020204" pitchFamily="34" charset="0"/>
-            </a:endParaRPr>
-          </a:p>
-          <a:p>
-            <a:pPr algn="just"/>
-            <a:endParaRPr lang="en-US" sz="3600" dirty="0">
-              <a:latin typeface="Arial" panose="020B0604020202020204" pitchFamily="34" charset="0"/>
-              <a:cs typeface="Arial" panose="020B0604020202020204" pitchFamily="34" charset="0"/>
-            </a:endParaRPr>
-          </a:p>
-          <a:p>
-            <a:pPr algn="just"/>
-            <a:endParaRPr lang="en-US" sz="3600" dirty="0">
-              <a:latin typeface="Arial" panose="020B0604020202020204" pitchFamily="34" charset="0"/>
-              <a:cs typeface="Arial" panose="020B0604020202020204" pitchFamily="34" charset="0"/>
-            </a:endParaRPr>
-          </a:p>
-          <a:p>
-            <a:pPr algn="just"/>
-            <a:endParaRPr lang="en-US" sz="3600" dirty="0">
-              <a:latin typeface="Arial" panose="020B0604020202020204" pitchFamily="34" charset="0"/>
-              <a:cs typeface="Arial" panose="020B0604020202020204" pitchFamily="34" charset="0"/>
-            </a:endParaRPr>
-          </a:p>
-          <a:p>
-            <a:pPr algn="just"/>
-            <a:endParaRPr lang="en-US" sz="3600" b="1" dirty="0">
-              <a:latin typeface="Arial" panose="020B0604020202020204" pitchFamily="34" charset="0"/>
-              <a:cs typeface="Arial" panose="020B0604020202020204" pitchFamily="34" charset="0"/>
-            </a:endParaRPr>
-          </a:p>
-          <a:p>
-            <a:pPr algn="just"/>
-            <a:r>
-              <a:rPr lang="en-US" sz="3600" b="1" dirty="0">
-                <a:latin typeface="Arial" panose="020B0604020202020204" pitchFamily="34" charset="0"/>
-                <a:cs typeface="Arial" panose="020B0604020202020204" pitchFamily="34" charset="0"/>
-              </a:rPr>
-              <a:t>FUZZY C-Means</a:t>
-            </a:r>
-          </a:p>
-          <a:p>
-            <a:pPr algn="just"/>
-            <a:r>
-              <a:rPr lang="en-US" sz="3600" dirty="0">
-                <a:latin typeface="Arial" panose="020B0604020202020204" pitchFamily="34" charset="0"/>
-                <a:cs typeface="Arial" panose="020B0604020202020204" pitchFamily="34" charset="0"/>
-              </a:rPr>
-              <a:t>Graph shows that massive power usage more than others but centroid recognized around 1.8. And mostly power usage around 0.3-0.7 which household power usage usually low, in other words, 70 percentage powers is low, 30 percent shows that normal usage and suddenly peak usage. </a:t>
-            </a:r>
-          </a:p>
-          <a:p>
-            <a:pPr algn="just"/>
-            <a:endParaRPr lang="en-US" sz="3600" dirty="0">
-              <a:latin typeface="Arial" panose="020B0604020202020204" pitchFamily="34" charset="0"/>
-              <a:cs typeface="Arial" panose="020B0604020202020204" pitchFamily="34" charset="0"/>
-            </a:endParaRPr>
-          </a:p>
-          <a:p>
-            <a:pPr algn="just"/>
-            <a:endParaRPr lang="en-US" sz="3600" dirty="0">
+              <a:t>Fuzzy C-Means</a:t>
+            </a:r>
+          </a:p>
+          <a:p>
+            <a:pPr algn="just"/>
+            <a:endParaRPr lang="en-US" sz="3200" b="1" dirty="0">
+              <a:latin typeface="Arial" panose="020B0604020202020204" pitchFamily="34" charset="0"/>
+              <a:cs typeface="Arial" panose="020B0604020202020204" pitchFamily="34" charset="0"/>
+            </a:endParaRPr>
+          </a:p>
+          <a:p>
+            <a:pPr algn="just"/>
+            <a:endParaRPr lang="en-US" sz="3200" b="1" dirty="0">
+              <a:latin typeface="Arial" panose="020B0604020202020204" pitchFamily="34" charset="0"/>
+              <a:cs typeface="Arial" panose="020B0604020202020204" pitchFamily="34" charset="0"/>
+            </a:endParaRPr>
+          </a:p>
+          <a:p>
+            <a:pPr algn="just"/>
+            <a:endParaRPr lang="en-US" sz="3200" b="1" dirty="0">
+              <a:latin typeface="Arial" panose="020B0604020202020204" pitchFamily="34" charset="0"/>
+              <a:cs typeface="Arial" panose="020B0604020202020204" pitchFamily="34" charset="0"/>
+            </a:endParaRPr>
+          </a:p>
+          <a:p>
+            <a:pPr algn="just"/>
+            <a:endParaRPr lang="en-US" sz="3200" b="1" dirty="0">
+              <a:latin typeface="Arial" panose="020B0604020202020204" pitchFamily="34" charset="0"/>
+              <a:cs typeface="Arial" panose="020B0604020202020204" pitchFamily="34" charset="0"/>
+            </a:endParaRPr>
+          </a:p>
+          <a:p>
+            <a:pPr algn="just"/>
+            <a:endParaRPr lang="en-US" sz="3200" b="1" dirty="0">
               <a:latin typeface="Arial" panose="020B0604020202020204" pitchFamily="34" charset="0"/>
               <a:cs typeface="Arial" panose="020B0604020202020204" pitchFamily="34" charset="0"/>
             </a:endParaRPr>
@@ -3579,98 +3959,13 @@
           </a:p>
           <a:p>
             <a:pPr algn="just"/>
-            <a:r>
-              <a:rPr lang="en-US" sz="4800" dirty="0">
-                <a:latin typeface="Arial" panose="020B0604020202020204" pitchFamily="34" charset="0"/>
-                <a:cs typeface="Arial" panose="020B0604020202020204" pitchFamily="34" charset="0"/>
-              </a:rPr>
-              <a:t>Graphs and compare the clusters and choose 2 and compare again, which cluster your </a:t>
-            </a:r>
-            <a:r>
-              <a:rPr lang="en-US" sz="4800" dirty="0" err="1">
-                <a:latin typeface="Arial" panose="020B0604020202020204" pitchFamily="34" charset="0"/>
-                <a:cs typeface="Arial" panose="020B0604020202020204" pitchFamily="34" charset="0"/>
-              </a:rPr>
-              <a:t>gonna</a:t>
-            </a:r>
-            <a:r>
-              <a:rPr lang="en-US" sz="4800" dirty="0">
-                <a:latin typeface="Arial" panose="020B0604020202020204" pitchFamily="34" charset="0"/>
-                <a:cs typeface="Arial" panose="020B0604020202020204" pitchFamily="34" charset="0"/>
-              </a:rPr>
-              <a:t> use, </a:t>
-            </a:r>
-            <a:r>
-              <a:rPr lang="en-US" sz="4800" dirty="0" err="1">
-                <a:latin typeface="Arial" panose="020B0604020202020204" pitchFamily="34" charset="0"/>
-                <a:cs typeface="Arial" panose="020B0604020202020204" pitchFamily="34" charset="0"/>
-              </a:rPr>
-              <a:t>silhoute</a:t>
-            </a:r>
-            <a:r>
-              <a:rPr lang="en-US" sz="4800" dirty="0">
-                <a:latin typeface="Arial" panose="020B0604020202020204" pitchFamily="34" charset="0"/>
-                <a:cs typeface="Arial" panose="020B0604020202020204" pitchFamily="34" charset="0"/>
-              </a:rPr>
-              <a:t> and </a:t>
-            </a:r>
-            <a:r>
-              <a:rPr lang="en-US" sz="4800" dirty="0" err="1">
-                <a:latin typeface="Arial" panose="020B0604020202020204" pitchFamily="34" charset="0"/>
-                <a:cs typeface="Arial" panose="020B0604020202020204" pitchFamily="34" charset="0"/>
-              </a:rPr>
-              <a:t>davis</a:t>
-            </a:r>
-            <a:r>
-              <a:rPr lang="en-US" sz="4800" dirty="0">
-                <a:latin typeface="Arial" panose="020B0604020202020204" pitchFamily="34" charset="0"/>
-                <a:cs typeface="Arial" panose="020B0604020202020204" pitchFamily="34" charset="0"/>
-              </a:rPr>
-              <a:t> what are difference? And compare result.</a:t>
-            </a:r>
-          </a:p>
-          <a:p>
-            <a:pPr algn="just"/>
-            <a:r>
-              <a:rPr lang="en-US" sz="4800" dirty="0">
-                <a:latin typeface="Arial" panose="020B0604020202020204" pitchFamily="34" charset="0"/>
-                <a:cs typeface="Arial" panose="020B0604020202020204" pitchFamily="34" charset="0"/>
-              </a:rPr>
-              <a:t> </a:t>
-            </a:r>
-          </a:p>
-        </p:txBody>
-      </p:sp>
-      <p:pic>
-        <p:nvPicPr>
-          <p:cNvPr id="20" name="Picture 19">
-            <a:extLst>
-              <a:ext uri="{FF2B5EF4-FFF2-40B4-BE49-F238E27FC236}">
-                <a16:creationId xmlns:a16="http://schemas.microsoft.com/office/drawing/2014/main" id="{2A53945F-AE64-5717-900A-CD159C660819}"/>
-              </a:ext>
-            </a:extLst>
-          </p:cNvPr>
-          <p:cNvPicPr>
-            <a:picLocks noChangeAspect="1"/>
-          </p:cNvPicPr>
-          <p:nvPr/>
-        </p:nvPicPr>
-        <p:blipFill>
-          <a:blip r:embed="rId2"/>
-          <a:stretch>
-            <a:fillRect/>
-          </a:stretch>
-        </p:blipFill>
-        <p:spPr>
-          <a:xfrm>
-            <a:off x="22088648" y="5852491"/>
-            <a:ext cx="5216235" cy="3634455"/>
-          </a:xfrm>
-          <a:prstGeom prst="rect">
-            <a:avLst/>
-          </a:prstGeom>
-        </p:spPr>
-      </p:pic>
+            <a:endParaRPr lang="en-US" sz="4800" dirty="0">
+              <a:latin typeface="Arial" panose="020B0604020202020204" pitchFamily="34" charset="0"/>
+              <a:cs typeface="Arial" panose="020B0604020202020204" pitchFamily="34" charset="0"/>
+            </a:endParaRPr>
+          </a:p>
+        </p:txBody>
+      </p:sp>
       <p:pic>
         <p:nvPicPr>
           <p:cNvPr id="22" name="Picture 21">
@@ -3693,8 +3988,8 @@
         </p:blipFill>
         <p:spPr>
           <a:xfrm>
-            <a:off x="16166176" y="5852491"/>
-            <a:ext cx="5216235" cy="3634455"/>
+            <a:off x="992476" y="6596690"/>
+            <a:ext cx="5481349" cy="3899884"/>
           </a:xfrm>
           <a:prstGeom prst="rect">
             <a:avLst/>
@@ -3723,8 +4018,8 @@
         </p:blipFill>
         <p:spPr>
           <a:xfrm>
-            <a:off x="21312641" y="19781510"/>
-            <a:ext cx="5216235" cy="3787468"/>
+            <a:off x="6495788" y="16438078"/>
+            <a:ext cx="5216235" cy="3899885"/>
           </a:xfrm>
           <a:prstGeom prst="rect">
             <a:avLst/>
@@ -3753,20 +4048,339 @@
         </p:blipFill>
         <p:spPr>
           <a:xfrm>
-            <a:off x="15610612" y="19781510"/>
-            <a:ext cx="5216235" cy="3856054"/>
+            <a:off x="1019503" y="16345799"/>
+            <a:ext cx="5216235" cy="3930487"/>
           </a:xfrm>
           <a:prstGeom prst="rect">
             <a:avLst/>
           </a:prstGeom>
         </p:spPr>
       </p:pic>
+      <p:sp>
+        <p:nvSpPr>
+          <p:cNvPr id="9" name="TextBox 8">
+            <a:extLst>
+              <a:ext uri="{FF2B5EF4-FFF2-40B4-BE49-F238E27FC236}">
+                <a16:creationId xmlns:a16="http://schemas.microsoft.com/office/drawing/2014/main" id="{E516117A-D4F6-AE31-505A-289B357469B4}"/>
+              </a:ext>
+            </a:extLst>
+          </p:cNvPr>
+          <p:cNvSpPr txBox="1"/>
+          <p:nvPr/>
+        </p:nvSpPr>
+        <p:spPr>
+          <a:xfrm>
+            <a:off x="22370444" y="5984188"/>
+            <a:ext cx="20528280" cy="20199096"/>
+          </a:xfrm>
+          <a:prstGeom prst="rect">
+            <a:avLst/>
+          </a:prstGeom>
+          <a:ln/>
+        </p:spPr>
+        <p:style>
+          <a:lnRef idx="2">
+            <a:schemeClr val="accent2"/>
+          </a:lnRef>
+          <a:fillRef idx="1">
+            <a:schemeClr val="lt1"/>
+          </a:fillRef>
+          <a:effectRef idx="0">
+            <a:schemeClr val="accent2"/>
+          </a:effectRef>
+          <a:fontRef idx="minor">
+            <a:schemeClr val="dk1"/>
+          </a:fontRef>
+        </p:style>
+        <p:txBody>
+          <a:bodyPr wrap="square" rtlCol="0">
+            <a:spAutoFit/>
+          </a:bodyPr>
+          <a:lstStyle/>
+          <a:p>
+            <a:pPr algn="just"/>
+            <a:r>
+              <a:rPr lang="en-US" sz="3200" b="1" dirty="0">
+                <a:solidFill>
+                  <a:schemeClr val="tx1"/>
+                </a:solidFill>
+                <a:latin typeface="Arial" panose="020B0604020202020204" pitchFamily="34" charset="0"/>
+                <a:cs typeface="Arial" panose="020B0604020202020204" pitchFamily="34" charset="0"/>
+              </a:rPr>
+              <a:t>Dickey-Fuller test</a:t>
+            </a:r>
+          </a:p>
+          <a:p>
+            <a:pPr algn="just"/>
+            <a:r>
+              <a:rPr lang="en-US" sz="3200" dirty="0">
+                <a:latin typeface="Arial" panose="020B0604020202020204" pitchFamily="34" charset="0"/>
+                <a:cs typeface="Arial" panose="020B0604020202020204" pitchFamily="34" charset="0"/>
+              </a:rPr>
+              <a:t>					</a:t>
+            </a:r>
+          </a:p>
+          <a:p>
+            <a:pPr algn="just"/>
+            <a:endParaRPr lang="en-US" sz="3200" dirty="0">
+              <a:latin typeface="Arial" panose="020B0604020202020204" pitchFamily="34" charset="0"/>
+              <a:cs typeface="Arial" panose="020B0604020202020204" pitchFamily="34" charset="0"/>
+            </a:endParaRPr>
+          </a:p>
+          <a:p>
+            <a:pPr algn="just"/>
+            <a:endParaRPr lang="en-US" sz="3200" dirty="0">
+              <a:latin typeface="Arial" panose="020B0604020202020204" pitchFamily="34" charset="0"/>
+              <a:cs typeface="Arial" panose="020B0604020202020204" pitchFamily="34" charset="0"/>
+            </a:endParaRPr>
+          </a:p>
+          <a:p>
+            <a:pPr algn="just"/>
+            <a:endParaRPr lang="en-US" sz="3200" dirty="0">
+              <a:latin typeface="Arial" panose="020B0604020202020204" pitchFamily="34" charset="0"/>
+              <a:cs typeface="Arial" panose="020B0604020202020204" pitchFamily="34" charset="0"/>
+            </a:endParaRPr>
+          </a:p>
+          <a:p>
+            <a:pPr algn="just"/>
+            <a:endParaRPr lang="en-US" sz="3200" dirty="0">
+              <a:latin typeface="Arial" panose="020B0604020202020204" pitchFamily="34" charset="0"/>
+              <a:cs typeface="Arial" panose="020B0604020202020204" pitchFamily="34" charset="0"/>
+            </a:endParaRPr>
+          </a:p>
+          <a:p>
+            <a:pPr algn="just"/>
+            <a:endParaRPr lang="en-US" sz="3200" dirty="0">
+              <a:latin typeface="Arial" panose="020B0604020202020204" pitchFamily="34" charset="0"/>
+              <a:cs typeface="Arial" panose="020B0604020202020204" pitchFamily="34" charset="0"/>
+            </a:endParaRPr>
+          </a:p>
+          <a:p>
+            <a:pPr algn="just"/>
+            <a:endParaRPr lang="en-US" sz="3200" dirty="0">
+              <a:latin typeface="Arial" panose="020B0604020202020204" pitchFamily="34" charset="0"/>
+              <a:cs typeface="Arial" panose="020B0604020202020204" pitchFamily="34" charset="0"/>
+            </a:endParaRPr>
+          </a:p>
+          <a:p>
+            <a:pPr algn="just"/>
+            <a:endParaRPr lang="en-US" sz="3200" dirty="0">
+              <a:latin typeface="Arial" panose="020B0604020202020204" pitchFamily="34" charset="0"/>
+              <a:cs typeface="Arial" panose="020B0604020202020204" pitchFamily="34" charset="0"/>
+            </a:endParaRPr>
+          </a:p>
+          <a:p>
+            <a:pPr algn="just"/>
+            <a:endParaRPr lang="en-US" sz="3200" b="1" dirty="0">
+              <a:latin typeface="Arial" panose="020B0604020202020204" pitchFamily="34" charset="0"/>
+              <a:cs typeface="Arial" panose="020B0604020202020204" pitchFamily="34" charset="0"/>
+            </a:endParaRPr>
+          </a:p>
+          <a:p>
+            <a:pPr algn="just"/>
+            <a:r>
+              <a:rPr lang="en-US" sz="3200" b="1" dirty="0">
+                <a:solidFill>
+                  <a:schemeClr val="tx1"/>
+                </a:solidFill>
+                <a:latin typeface="Arial" panose="020B0604020202020204" pitchFamily="34" charset="0"/>
+                <a:cs typeface="Arial" panose="020B0604020202020204" pitchFamily="34" charset="0"/>
+              </a:rPr>
+              <a:t>ARIMA and SARIMA</a:t>
+            </a:r>
+          </a:p>
+          <a:p>
+            <a:pPr algn="just"/>
+            <a:endParaRPr lang="en-US" sz="3200" b="1" dirty="0">
+              <a:latin typeface="Arial" panose="020B0604020202020204" pitchFamily="34" charset="0"/>
+              <a:cs typeface="Arial" panose="020B0604020202020204" pitchFamily="34" charset="0"/>
+            </a:endParaRPr>
+          </a:p>
+          <a:p>
+            <a:pPr algn="just"/>
+            <a:endParaRPr lang="en-US" sz="3200" b="1" dirty="0">
+              <a:latin typeface="Arial" panose="020B0604020202020204" pitchFamily="34" charset="0"/>
+              <a:cs typeface="Arial" panose="020B0604020202020204" pitchFamily="34" charset="0"/>
+            </a:endParaRPr>
+          </a:p>
+          <a:p>
+            <a:pPr algn="just"/>
+            <a:endParaRPr lang="en-US" sz="3200" b="1" dirty="0">
+              <a:latin typeface="Arial" panose="020B0604020202020204" pitchFamily="34" charset="0"/>
+              <a:cs typeface="Arial" panose="020B0604020202020204" pitchFamily="34" charset="0"/>
+            </a:endParaRPr>
+          </a:p>
+          <a:p>
+            <a:pPr algn="just"/>
+            <a:endParaRPr lang="en-US" sz="3200" b="1" dirty="0">
+              <a:latin typeface="Arial" panose="020B0604020202020204" pitchFamily="34" charset="0"/>
+              <a:cs typeface="Arial" panose="020B0604020202020204" pitchFamily="34" charset="0"/>
+            </a:endParaRPr>
+          </a:p>
+          <a:p>
+            <a:pPr algn="just"/>
+            <a:endParaRPr lang="en-US" sz="3200" b="1" dirty="0">
+              <a:latin typeface="Arial" panose="020B0604020202020204" pitchFamily="34" charset="0"/>
+              <a:cs typeface="Arial" panose="020B0604020202020204" pitchFamily="34" charset="0"/>
+            </a:endParaRPr>
+          </a:p>
+          <a:p>
+            <a:pPr algn="just"/>
+            <a:endParaRPr lang="en-US" sz="3200" b="1" dirty="0">
+              <a:latin typeface="Arial" panose="020B0604020202020204" pitchFamily="34" charset="0"/>
+              <a:cs typeface="Arial" panose="020B0604020202020204" pitchFamily="34" charset="0"/>
+            </a:endParaRPr>
+          </a:p>
+          <a:p>
+            <a:pPr algn="just"/>
+            <a:endParaRPr lang="en-US" sz="3200" b="1" dirty="0">
+              <a:latin typeface="Arial" panose="020B0604020202020204" pitchFamily="34" charset="0"/>
+              <a:cs typeface="Arial" panose="020B0604020202020204" pitchFamily="34" charset="0"/>
+            </a:endParaRPr>
+          </a:p>
+          <a:p>
+            <a:pPr algn="just"/>
+            <a:endParaRPr lang="en-US" sz="3200" b="1" dirty="0">
+              <a:latin typeface="Arial" panose="020B0604020202020204" pitchFamily="34" charset="0"/>
+              <a:cs typeface="Arial" panose="020B0604020202020204" pitchFamily="34" charset="0"/>
+            </a:endParaRPr>
+          </a:p>
+          <a:p>
+            <a:pPr algn="just"/>
+            <a:endParaRPr lang="en-US" sz="3200" b="1" dirty="0">
+              <a:latin typeface="Arial" panose="020B0604020202020204" pitchFamily="34" charset="0"/>
+              <a:cs typeface="Arial" panose="020B0604020202020204" pitchFamily="34" charset="0"/>
+            </a:endParaRPr>
+          </a:p>
+          <a:p>
+            <a:pPr algn="just"/>
+            <a:endParaRPr lang="en-US" sz="3200" b="1" dirty="0">
+              <a:latin typeface="Arial" panose="020B0604020202020204" pitchFamily="34" charset="0"/>
+              <a:cs typeface="Arial" panose="020B0604020202020204" pitchFamily="34" charset="0"/>
+            </a:endParaRPr>
+          </a:p>
+          <a:p>
+            <a:pPr algn="just"/>
+            <a:endParaRPr lang="en-US" sz="3200" dirty="0">
+              <a:latin typeface="Arial" panose="020B0604020202020204" pitchFamily="34" charset="0"/>
+              <a:cs typeface="Arial" panose="020B0604020202020204" pitchFamily="34" charset="0"/>
+            </a:endParaRPr>
+          </a:p>
+          <a:p>
+            <a:pPr algn="just"/>
+            <a:endParaRPr lang="en-US" sz="3200" dirty="0">
+              <a:latin typeface="Arial" panose="020B0604020202020204" pitchFamily="34" charset="0"/>
+              <a:cs typeface="Arial" panose="020B0604020202020204" pitchFamily="34" charset="0"/>
+            </a:endParaRPr>
+          </a:p>
+          <a:p>
+            <a:pPr algn="just"/>
+            <a:endParaRPr lang="en-US" sz="3200" dirty="0">
+              <a:latin typeface="Arial" panose="020B0604020202020204" pitchFamily="34" charset="0"/>
+              <a:cs typeface="Arial" panose="020B0604020202020204" pitchFamily="34" charset="0"/>
+            </a:endParaRPr>
+          </a:p>
+          <a:p>
+            <a:pPr algn="just"/>
+            <a:endParaRPr lang="en-US" sz="3200" b="1" dirty="0">
+              <a:latin typeface="Arial" panose="020B0604020202020204" pitchFamily="34" charset="0"/>
+              <a:cs typeface="Arial" panose="020B0604020202020204" pitchFamily="34" charset="0"/>
+            </a:endParaRPr>
+          </a:p>
+          <a:p>
+            <a:pPr algn="just"/>
+            <a:endParaRPr lang="en-US" sz="3200" b="1" dirty="0">
+              <a:latin typeface="Arial" panose="020B0604020202020204" pitchFamily="34" charset="0"/>
+              <a:cs typeface="Arial" panose="020B0604020202020204" pitchFamily="34" charset="0"/>
+            </a:endParaRPr>
+          </a:p>
+          <a:p>
+            <a:pPr algn="just"/>
+            <a:endParaRPr lang="en-US" sz="3200" b="1" dirty="0">
+              <a:latin typeface="Arial" panose="020B0604020202020204" pitchFamily="34" charset="0"/>
+              <a:cs typeface="Arial" panose="020B0604020202020204" pitchFamily="34" charset="0"/>
+            </a:endParaRPr>
+          </a:p>
+          <a:p>
+            <a:pPr algn="just"/>
+            <a:endParaRPr lang="en-US" sz="3200" b="1" dirty="0">
+              <a:latin typeface="Arial" panose="020B0604020202020204" pitchFamily="34" charset="0"/>
+              <a:cs typeface="Arial" panose="020B0604020202020204" pitchFamily="34" charset="0"/>
+            </a:endParaRPr>
+          </a:p>
+          <a:p>
+            <a:pPr algn="just"/>
+            <a:endParaRPr lang="en-US" sz="3200" b="1" dirty="0">
+              <a:latin typeface="Arial" panose="020B0604020202020204" pitchFamily="34" charset="0"/>
+              <a:cs typeface="Arial" panose="020B0604020202020204" pitchFamily="34" charset="0"/>
+            </a:endParaRPr>
+          </a:p>
+          <a:p>
+            <a:pPr algn="just"/>
+            <a:endParaRPr lang="en-US" sz="3200" b="1" dirty="0">
+              <a:latin typeface="Arial" panose="020B0604020202020204" pitchFamily="34" charset="0"/>
+              <a:cs typeface="Arial" panose="020B0604020202020204" pitchFamily="34" charset="0"/>
+            </a:endParaRPr>
+          </a:p>
+          <a:p>
+            <a:pPr algn="just"/>
+            <a:r>
+              <a:rPr lang="en-US" sz="3200" b="1" dirty="0">
+                <a:solidFill>
+                  <a:schemeClr val="tx1"/>
+                </a:solidFill>
+                <a:latin typeface="Arial" panose="020B0604020202020204" pitchFamily="34" charset="0"/>
+                <a:cs typeface="Arial" panose="020B0604020202020204" pitchFamily="34" charset="0"/>
+              </a:rPr>
+              <a:t>Holt-Winters model</a:t>
+            </a:r>
+          </a:p>
+          <a:p>
+            <a:pPr algn="just"/>
+            <a:endParaRPr lang="en-US" sz="3200" b="1" dirty="0">
+              <a:latin typeface="Arial" panose="020B0604020202020204" pitchFamily="34" charset="0"/>
+              <a:cs typeface="Arial" panose="020B0604020202020204" pitchFamily="34" charset="0"/>
+            </a:endParaRPr>
+          </a:p>
+          <a:p>
+            <a:pPr algn="just"/>
+            <a:endParaRPr lang="en-US" sz="3200" b="1" dirty="0">
+              <a:latin typeface="Arial" panose="020B0604020202020204" pitchFamily="34" charset="0"/>
+              <a:cs typeface="Arial" panose="020B0604020202020204" pitchFamily="34" charset="0"/>
+            </a:endParaRPr>
+          </a:p>
+          <a:p>
+            <a:pPr algn="just"/>
+            <a:endParaRPr lang="en-US" sz="3600" dirty="0">
+              <a:solidFill>
+                <a:srgbClr val="FF0000"/>
+              </a:solidFill>
+              <a:latin typeface="Arial" panose="020B0604020202020204" pitchFamily="34" charset="0"/>
+              <a:cs typeface="Arial" panose="020B0604020202020204" pitchFamily="34" charset="0"/>
+            </a:endParaRPr>
+          </a:p>
+          <a:p>
+            <a:pPr algn="just"/>
+            <a:endParaRPr lang="en-US" sz="4800" dirty="0">
+              <a:latin typeface="Arial" panose="020B0604020202020204" pitchFamily="34" charset="0"/>
+              <a:cs typeface="Arial" panose="020B0604020202020204" pitchFamily="34" charset="0"/>
+            </a:endParaRPr>
+          </a:p>
+          <a:p>
+            <a:pPr algn="just"/>
+            <a:endParaRPr lang="en-US" sz="4800" dirty="0">
+              <a:latin typeface="Arial" panose="020B0604020202020204" pitchFamily="34" charset="0"/>
+              <a:cs typeface="Arial" panose="020B0604020202020204" pitchFamily="34" charset="0"/>
+            </a:endParaRPr>
+          </a:p>
+        </p:txBody>
+      </p:sp>
       <p:pic>
         <p:nvPicPr>
-          <p:cNvPr id="7" name="Picture 6">
+          <p:cNvPr id="8" name="Picture 7">
             <a:extLst>
               <a:ext uri="{FF2B5EF4-FFF2-40B4-BE49-F238E27FC236}">
-                <a16:creationId xmlns:a16="http://schemas.microsoft.com/office/drawing/2014/main" id="{B44CF3C5-FA8C-0F9E-DA66-1178A0BE2203}"/>
+                <a16:creationId xmlns:a16="http://schemas.microsoft.com/office/drawing/2014/main" id="{B3C38F93-2715-A61F-208B-534B4E5418C0}"/>
               </a:ext>
             </a:extLst>
           </p:cNvPr>
@@ -3783,8 +4397,8 @@
         </p:blipFill>
         <p:spPr>
           <a:xfrm>
-            <a:off x="15367715" y="28231536"/>
-            <a:ext cx="10918264" cy="3634455"/>
+            <a:off x="1046353" y="11438853"/>
+            <a:ext cx="10616010" cy="3899884"/>
           </a:xfrm>
           <a:prstGeom prst="rect">
             <a:avLst/>
@@ -3793,10 +4407,10 @@
       </p:pic>
       <p:sp>
         <p:nvSpPr>
-          <p:cNvPr id="9" name="TextBox 8">
+          <p:cNvPr id="10" name="TextBox 9">
             <a:extLst>
               <a:ext uri="{FF2B5EF4-FFF2-40B4-BE49-F238E27FC236}">
-                <a16:creationId xmlns:a16="http://schemas.microsoft.com/office/drawing/2014/main" id="{E516117A-D4F6-AE31-505A-289B357469B4}"/>
+                <a16:creationId xmlns:a16="http://schemas.microsoft.com/office/drawing/2014/main" id="{444E9714-CA08-DAE2-DBC9-A6E2F29315A9}"/>
               </a:ext>
             </a:extLst>
           </p:cNvPr>
@@ -3805,8 +4419,288 @@
         </p:nvSpPr>
         <p:spPr>
           <a:xfrm>
-            <a:off x="30123938" y="2014106"/>
-            <a:ext cx="12448651" cy="6001643"/>
+            <a:off x="992474" y="742390"/>
+            <a:ext cx="41906249" cy="1938992"/>
+          </a:xfrm>
+          <a:prstGeom prst="rect">
+            <a:avLst/>
+          </a:prstGeom>
+          <a:ln/>
+        </p:spPr>
+        <p:style>
+          <a:lnRef idx="2">
+            <a:schemeClr val="accent2"/>
+          </a:lnRef>
+          <a:fillRef idx="1">
+            <a:schemeClr val="lt1"/>
+          </a:fillRef>
+          <a:effectRef idx="0">
+            <a:schemeClr val="accent2"/>
+          </a:effectRef>
+          <a:fontRef idx="minor">
+            <a:schemeClr val="dk1"/>
+          </a:fontRef>
+        </p:style>
+        <p:txBody>
+          <a:bodyPr wrap="square" rtlCol="0">
+            <a:spAutoFit/>
+          </a:bodyPr>
+          <a:lstStyle/>
+          <a:p>
+            <a:pPr algn="ctr"/>
+            <a:r>
+              <a:rPr lang="en-US" sz="4400" b="1" dirty="0">
+                <a:solidFill>
+                  <a:schemeClr val="tx1"/>
+                </a:solidFill>
+                <a:latin typeface="Arial" panose="020B0604020202020204" pitchFamily="34" charset="0"/>
+                <a:cs typeface="Arial" panose="020B0604020202020204" pitchFamily="34" charset="0"/>
+              </a:rPr>
+              <a:t>INDIVIDUAL HOUSEHOLD ELECTRICITY CONSUMPTION DATA FOR CLUSTERING AND TIME SERIES MODEL</a:t>
+            </a:r>
+          </a:p>
+          <a:p>
+            <a:pPr algn="ctr"/>
+            <a:r>
+              <a:rPr lang="en-US" sz="3600" dirty="0">
+                <a:solidFill>
+                  <a:schemeClr val="tx1"/>
+                </a:solidFill>
+                <a:latin typeface="Arial" panose="020B0604020202020204" pitchFamily="34" charset="0"/>
+                <a:cs typeface="Arial" panose="020B0604020202020204" pitchFamily="34" charset="0"/>
+              </a:rPr>
+              <a:t>						</a:t>
+            </a:r>
+          </a:p>
+          <a:p>
+            <a:pPr algn="ctr"/>
+            <a:r>
+              <a:rPr lang="en-US" sz="4000" dirty="0">
+                <a:solidFill>
+                  <a:schemeClr val="tx1"/>
+                </a:solidFill>
+                <a:latin typeface="Arial" panose="020B0604020202020204" pitchFamily="34" charset="0"/>
+                <a:cs typeface="Arial" panose="020B0604020202020204" pitchFamily="34" charset="0"/>
+              </a:rPr>
+              <a:t>Enkhbayasgalan Batbayar, CCT College, 10/16/2026</a:t>
+            </a:r>
+            <a:endParaRPr lang="en-US" sz="3200" dirty="0">
+              <a:solidFill>
+                <a:schemeClr val="tx1"/>
+              </a:solidFill>
+              <a:latin typeface="Arial" panose="020B0604020202020204" pitchFamily="34" charset="0"/>
+              <a:cs typeface="Arial" panose="020B0604020202020204" pitchFamily="34" charset="0"/>
+            </a:endParaRPr>
+          </a:p>
+        </p:txBody>
+      </p:sp>
+      <p:sp>
+        <p:nvSpPr>
+          <p:cNvPr id="21" name="TextBox 20">
+            <a:extLst>
+              <a:ext uri="{FF2B5EF4-FFF2-40B4-BE49-F238E27FC236}">
+                <a16:creationId xmlns:a16="http://schemas.microsoft.com/office/drawing/2014/main" id="{DD948F85-DE0B-7B6C-D1EF-22E9E2257C89}"/>
+              </a:ext>
+            </a:extLst>
+          </p:cNvPr>
+          <p:cNvSpPr txBox="1"/>
+          <p:nvPr/>
+        </p:nvSpPr>
+        <p:spPr>
+          <a:xfrm>
+            <a:off x="861536" y="27085433"/>
+            <a:ext cx="41682600" cy="2554545"/>
+          </a:xfrm>
+          <a:prstGeom prst="rect">
+            <a:avLst/>
+          </a:prstGeom>
+          <a:ln/>
+        </p:spPr>
+        <p:style>
+          <a:lnRef idx="2">
+            <a:schemeClr val="accent2"/>
+          </a:lnRef>
+          <a:fillRef idx="1">
+            <a:schemeClr val="lt1"/>
+          </a:fillRef>
+          <a:effectRef idx="0">
+            <a:schemeClr val="accent2"/>
+          </a:effectRef>
+          <a:fontRef idx="minor">
+            <a:schemeClr val="dk1"/>
+          </a:fontRef>
+        </p:style>
+        <p:txBody>
+          <a:bodyPr wrap="square" rtlCol="0">
+            <a:spAutoFit/>
+          </a:bodyPr>
+          <a:lstStyle/>
+          <a:p>
+            <a:r>
+              <a:rPr lang="en-US" sz="3200" b="1" i="1" dirty="0">
+                <a:solidFill>
+                  <a:schemeClr val="tx1"/>
+                </a:solidFill>
+                <a:latin typeface="Arial" panose="020B0604020202020204" pitchFamily="34" charset="0"/>
+                <a:cs typeface="Arial" panose="020B0604020202020204" pitchFamily="34" charset="0"/>
+              </a:rPr>
+              <a:t>RESULT</a:t>
+            </a:r>
+          </a:p>
+          <a:p>
+            <a:r>
+              <a:rPr lang="en-US" sz="3200" b="1" i="1" dirty="0">
+                <a:solidFill>
+                  <a:schemeClr val="tx1"/>
+                </a:solidFill>
+                <a:latin typeface="Arial" panose="020B0604020202020204" pitchFamily="34" charset="0"/>
+                <a:cs typeface="Arial" panose="020B0604020202020204" pitchFamily="34" charset="0"/>
+              </a:rPr>
+              <a:t>Cluster models have been identified showing that household power usage is usually low, but in the mornings and evenings it is higher than at normal times. Optimal cluster is 4 both Davis-Boulding and </a:t>
+            </a:r>
+            <a:r>
+              <a:rPr lang="en-US" sz="3200" b="1" i="1" dirty="0" err="1">
+                <a:solidFill>
+                  <a:schemeClr val="tx1"/>
+                </a:solidFill>
+                <a:latin typeface="Arial" panose="020B0604020202020204" pitchFamily="34" charset="0"/>
+                <a:cs typeface="Arial" panose="020B0604020202020204" pitchFamily="34" charset="0"/>
+              </a:rPr>
+              <a:t>Silhoutte</a:t>
+            </a:r>
+            <a:r>
+              <a:rPr lang="en-US" sz="3200" b="1" i="1" dirty="0">
+                <a:solidFill>
+                  <a:schemeClr val="tx1"/>
+                </a:solidFill>
+                <a:latin typeface="Arial" panose="020B0604020202020204" pitchFamily="34" charset="0"/>
+                <a:cs typeface="Arial" panose="020B0604020202020204" pitchFamily="34" charset="0"/>
+              </a:rPr>
+              <a:t> on the DBSCAN and Fuzzy C-Means. For K-means, the Davis-Bouldin index is 4, but the Silhouette score is 2.</a:t>
+            </a:r>
+          </a:p>
+          <a:p>
+            <a:r>
+              <a:rPr lang="en-US" sz="3200" b="1" i="1" dirty="0">
+                <a:solidFill>
+                  <a:schemeClr val="tx1"/>
+                </a:solidFill>
+                <a:latin typeface="Arial" panose="020B0604020202020204" pitchFamily="34" charset="0"/>
+                <a:cs typeface="Arial" panose="020B0604020202020204" pitchFamily="34" charset="0"/>
+              </a:rPr>
+              <a:t>I used the SARIMA model because the data is stationary and has seasonality; it explained 0.97 percent of the data. Household past 2 hours usage depict next one hour usage and during night power usage unexpectedly peaks may be electronic devices require more power or use heaters during that time. Next 120, household usage will drop.        </a:t>
+            </a:r>
+          </a:p>
+        </p:txBody>
+      </p:sp>
+      <p:sp>
+        <p:nvSpPr>
+          <p:cNvPr id="24" name="TextBox 23">
+            <a:extLst>
+              <a:ext uri="{FF2B5EF4-FFF2-40B4-BE49-F238E27FC236}">
+                <a16:creationId xmlns:a16="http://schemas.microsoft.com/office/drawing/2014/main" id="{8E256DB8-149C-03B1-B002-718E628C99C8}"/>
+              </a:ext>
+            </a:extLst>
+          </p:cNvPr>
+          <p:cNvSpPr txBox="1"/>
+          <p:nvPr/>
+        </p:nvSpPr>
+        <p:spPr>
+          <a:xfrm>
+            <a:off x="889574" y="29907237"/>
+            <a:ext cx="41677415" cy="584775"/>
+          </a:xfrm>
+          <a:prstGeom prst="rect">
+            <a:avLst/>
+          </a:prstGeom>
+          <a:ln/>
+        </p:spPr>
+        <p:style>
+          <a:lnRef idx="2">
+            <a:schemeClr val="accent2"/>
+          </a:lnRef>
+          <a:fillRef idx="1">
+            <a:schemeClr val="lt1"/>
+          </a:fillRef>
+          <a:effectRef idx="0">
+            <a:schemeClr val="accent2"/>
+          </a:effectRef>
+          <a:fontRef idx="minor">
+            <a:schemeClr val="dk1"/>
+          </a:fontRef>
+        </p:style>
+        <p:txBody>
+          <a:bodyPr wrap="square" rtlCol="0">
+            <a:spAutoFit/>
+          </a:bodyPr>
+          <a:lstStyle/>
+          <a:p>
+            <a:r>
+              <a:rPr lang="en-US" sz="3200" b="1" i="1" dirty="0">
+                <a:solidFill>
+                  <a:schemeClr val="tx1"/>
+                </a:solidFill>
+                <a:latin typeface="Arial" panose="020B0604020202020204" pitchFamily="34" charset="0"/>
+                <a:cs typeface="Arial" panose="020B0604020202020204" pitchFamily="34" charset="0"/>
+              </a:rPr>
+              <a:t>REFERENCE</a:t>
+            </a:r>
+            <a:r>
+              <a:rPr lang="en-US" sz="3200" b="1" i="1" dirty="0">
+                <a:latin typeface="Arial" panose="020B0604020202020204" pitchFamily="34" charset="0"/>
+                <a:cs typeface="Arial" panose="020B0604020202020204" pitchFamily="34" charset="0"/>
+              </a:rPr>
+              <a:t> </a:t>
+            </a:r>
+          </a:p>
+        </p:txBody>
+      </p:sp>
+      <p:pic>
+        <p:nvPicPr>
+          <p:cNvPr id="26" name="Picture 25">
+            <a:extLst>
+              <a:ext uri="{FF2B5EF4-FFF2-40B4-BE49-F238E27FC236}">
+                <a16:creationId xmlns:a16="http://schemas.microsoft.com/office/drawing/2014/main" id="{70059032-9A0F-D7C5-458C-FC4121B1CDBE}"/>
+              </a:ext>
+            </a:extLst>
+          </p:cNvPr>
+          <p:cNvPicPr>
+            <a:picLocks noChangeAspect="1"/>
+          </p:cNvPicPr>
+          <p:nvPr/>
+        </p:nvPicPr>
+        <p:blipFill>
+          <a:blip r:embed="rId7"/>
+          <a:stretch>
+            <a:fillRect/>
+          </a:stretch>
+        </p:blipFill>
+        <p:spPr>
+          <a:xfrm>
+            <a:off x="22284626" y="6596429"/>
+            <a:ext cx="7324094" cy="3977881"/>
+          </a:xfrm>
+          <a:prstGeom prst="rect">
+            <a:avLst/>
+          </a:prstGeom>
+        </p:spPr>
+      </p:pic>
+      <p:sp>
+        <p:nvSpPr>
+          <p:cNvPr id="34" name="TextBox 33">
+            <a:extLst>
+              <a:ext uri="{FF2B5EF4-FFF2-40B4-BE49-F238E27FC236}">
+                <a16:creationId xmlns:a16="http://schemas.microsoft.com/office/drawing/2014/main" id="{975525CD-935B-818C-F2F7-7814377EE05B}"/>
+              </a:ext>
+            </a:extLst>
+          </p:cNvPr>
+          <p:cNvSpPr txBox="1"/>
+          <p:nvPr/>
+        </p:nvSpPr>
+        <p:spPr>
+          <a:xfrm>
+            <a:off x="29816538" y="6394914"/>
+            <a:ext cx="12677493" cy="4893647"/>
           </a:xfrm>
           <a:prstGeom prst="rect">
             <a:avLst/>
@@ -3821,62 +4715,41 @@
           <a:p>
             <a:pPr algn="just"/>
             <a:r>
-              <a:rPr lang="en-US" sz="3600" b="1" dirty="0">
+              <a:rPr lang="en-US" sz="4400" dirty="0">
                 <a:latin typeface="Arial" panose="020B0604020202020204" pitchFamily="34" charset="0"/>
                 <a:cs typeface="Arial" panose="020B0604020202020204" pitchFamily="34" charset="0"/>
               </a:rPr>
-              <a:t>Dickey-Fuller test</a:t>
-            </a:r>
-          </a:p>
-          <a:p>
-            <a:pPr algn="just"/>
-            <a:r>
-              <a:rPr lang="en-US" sz="3600" dirty="0">
+              <a:t>	</a:t>
+            </a:r>
+            <a:r>
+              <a:rPr lang="en-US" sz="2800" dirty="0">
                 <a:latin typeface="Arial" panose="020B0604020202020204" pitchFamily="34" charset="0"/>
                 <a:cs typeface="Arial" panose="020B0604020202020204" pitchFamily="34" charset="0"/>
               </a:rPr>
-              <a:t>The graph shows that the data is stationary due test result is  0.00000058 as reject the null hypothesis. </a:t>
-            </a:r>
-            <a:r>
-              <a:rPr lang="en-US" sz="3600" dirty="0">
-                <a:solidFill>
-                  <a:srgbClr val="FF0000"/>
-                </a:solidFill>
+              <a:t>The graph shows that the data is stationary due to test result is  0.016 as rejected the null hypothesis. But the data is seasonal because nighttime around 10:00 PM to 1AM hour power usage reach low level as use 1 kilowatts, in despite, at 7 AM to 12PM it reaches high level again decreased 12 PM to 2 PM, then evening 5 PM to 8 PM is constantly high as use 3.3 to 3.8 kilowatt. And, autocorrelation and partial autocorrelation prove that the data has seasonality.</a:t>
+            </a:r>
+          </a:p>
+          <a:p>
+            <a:pPr algn="just"/>
+            <a:r>
+              <a:rPr lang="en-US" sz="2800" dirty="0">
                 <a:latin typeface="Arial" panose="020B0604020202020204" pitchFamily="34" charset="0"/>
                 <a:cs typeface="Arial" panose="020B0604020202020204" pitchFamily="34" charset="0"/>
               </a:rPr>
-              <a:t>But the data is seasonal because October to March electricity usage increased and constantly decreased from April, In despite June to August it reach low level. </a:t>
-            </a:r>
-            <a:r>
-              <a:rPr lang="en-US" sz="3600" dirty="0">
-                <a:latin typeface="Arial" panose="020B0604020202020204" pitchFamily="34" charset="0"/>
-                <a:cs typeface="Arial" panose="020B0604020202020204" pitchFamily="34" charset="0"/>
-              </a:rPr>
-              <a:t>So, SARIMA model has been used further because the data is stationary but has seasonality. </a:t>
-            </a:r>
-          </a:p>
-          <a:p>
-            <a:pPr algn="just"/>
-            <a:endParaRPr lang="en-US" sz="4800" dirty="0">
-              <a:latin typeface="Arial" panose="020B0604020202020204" pitchFamily="34" charset="0"/>
-              <a:cs typeface="Arial" panose="020B0604020202020204" pitchFamily="34" charset="0"/>
-            </a:endParaRPr>
-          </a:p>
-          <a:p>
-            <a:pPr algn="just"/>
-            <a:endParaRPr lang="en-US" sz="4800" dirty="0">
-              <a:latin typeface="Arial" panose="020B0604020202020204" pitchFamily="34" charset="0"/>
-              <a:cs typeface="Arial" panose="020B0604020202020204" pitchFamily="34" charset="0"/>
-            </a:endParaRPr>
-          </a:p>
-        </p:txBody>
-      </p:sp>
-      <p:sp>
-        <p:nvSpPr>
-          <p:cNvPr id="12" name="TextBox 11">
+              <a:t>So, the SARIMA model was used further because the data is stationary but has seasonality. </a:t>
+            </a:r>
+          </a:p>
+          <a:p>
+            <a:endParaRPr lang="en-US" sz="4400" dirty="0"/>
+          </a:p>
+        </p:txBody>
+      </p:sp>
+      <p:sp>
+        <p:nvSpPr>
+          <p:cNvPr id="11" name="TextBox 10">
             <a:extLst>
               <a:ext uri="{FF2B5EF4-FFF2-40B4-BE49-F238E27FC236}">
-                <a16:creationId xmlns:a16="http://schemas.microsoft.com/office/drawing/2014/main" id="{854A45D1-5840-50C3-BC01-1A6675817271}"/>
+                <a16:creationId xmlns:a16="http://schemas.microsoft.com/office/drawing/2014/main" id="{588B8337-4A27-BEEE-367E-D5164BB4E45D}"/>
               </a:ext>
             </a:extLst>
           </p:cNvPr>
@@ -3885,8 +4758,8 @@
         </p:nvSpPr>
         <p:spPr>
           <a:xfrm>
-            <a:off x="1318610" y="997528"/>
-            <a:ext cx="12843162" cy="707886"/>
+            <a:off x="11750933" y="6504576"/>
+            <a:ext cx="9067344" cy="3970318"/>
           </a:xfrm>
           <a:prstGeom prst="rect">
             <a:avLst/>
@@ -3899,17 +4772,605 @@
           </a:bodyPr>
           <a:lstStyle/>
           <a:p>
-            <a:r>
-              <a:rPr lang="en-US" sz="4000" b="1" dirty="0">
+            <a:pPr algn="just"/>
+            <a:r>
+              <a:rPr lang="en-US" sz="2800" dirty="0">
                 <a:latin typeface="Arial" panose="020B0604020202020204" pitchFamily="34" charset="0"/>
                 <a:cs typeface="Arial" panose="020B0604020202020204" pitchFamily="34" charset="0"/>
               </a:rPr>
-              <a:t>INTRODUCTION</a:t>
-            </a:r>
-            <a:endParaRPr lang="en-US" dirty="0"/>
-          </a:p>
-        </p:txBody>
-      </p:sp>
+              <a:t>	Data has been clustered into 4 groups. Household electricity consumption in the morning and at night is higher, usage during those times 2.5 to 3.4. In despite of Afternoon usage reaching to lowest level. The evening, average power consumption is 0.8. </a:t>
+            </a:r>
+          </a:p>
+          <a:p>
+            <a:pPr algn="just"/>
+            <a:r>
+              <a:rPr lang="en-US" sz="2800" dirty="0">
+                <a:latin typeface="Arial" panose="020B0604020202020204" pitchFamily="34" charset="0"/>
+                <a:cs typeface="Arial" panose="020B0604020202020204" pitchFamily="34" charset="0"/>
+              </a:rPr>
+              <a:t>	The elbow method and Davies-Bouldin index showed the optimal number is 4. The Silhouette score showed that 2 or 3 clusters will predict better, at 40-42 percent. </a:t>
+            </a:r>
+          </a:p>
+          <a:p>
+            <a:endParaRPr lang="en-US" sz="2800" dirty="0"/>
+          </a:p>
+        </p:txBody>
+      </p:sp>
+      <p:sp>
+        <p:nvSpPr>
+          <p:cNvPr id="14" name="TextBox 13">
+            <a:extLst>
+              <a:ext uri="{FF2B5EF4-FFF2-40B4-BE49-F238E27FC236}">
+                <a16:creationId xmlns:a16="http://schemas.microsoft.com/office/drawing/2014/main" id="{A19056F8-1B4B-BC97-194C-B320E5A21880}"/>
+              </a:ext>
+            </a:extLst>
+          </p:cNvPr>
+          <p:cNvSpPr txBox="1"/>
+          <p:nvPr/>
+        </p:nvSpPr>
+        <p:spPr>
+          <a:xfrm>
+            <a:off x="12087765" y="14903266"/>
+            <a:ext cx="9207719" cy="523220"/>
+          </a:xfrm>
+          <a:prstGeom prst="rect">
+            <a:avLst/>
+          </a:prstGeom>
+          <a:noFill/>
+        </p:spPr>
+        <p:txBody>
+          <a:bodyPr wrap="square" rtlCol="0">
+            <a:spAutoFit/>
+          </a:bodyPr>
+          <a:lstStyle/>
+          <a:p>
+            <a:pPr algn="just"/>
+            <a:r>
+              <a:rPr lang="en-US" sz="2800" dirty="0">
+                <a:latin typeface="Arial" panose="020B0604020202020204" pitchFamily="34" charset="0"/>
+                <a:cs typeface="Arial" panose="020B0604020202020204" pitchFamily="34" charset="0"/>
+              </a:rPr>
+              <a:t>	</a:t>
+            </a:r>
+            <a:endParaRPr lang="en-US" sz="2800" dirty="0"/>
+          </a:p>
+        </p:txBody>
+      </p:sp>
+      <p:sp>
+        <p:nvSpPr>
+          <p:cNvPr id="18" name="TextBox 17">
+            <a:extLst>
+              <a:ext uri="{FF2B5EF4-FFF2-40B4-BE49-F238E27FC236}">
+                <a16:creationId xmlns:a16="http://schemas.microsoft.com/office/drawing/2014/main" id="{E558EF13-864D-7CF3-64F6-F004A705B3A2}"/>
+              </a:ext>
+            </a:extLst>
+          </p:cNvPr>
+          <p:cNvSpPr txBox="1"/>
+          <p:nvPr/>
+        </p:nvSpPr>
+        <p:spPr>
+          <a:xfrm>
+            <a:off x="11631088" y="11374311"/>
+            <a:ext cx="9207719" cy="2677656"/>
+          </a:xfrm>
+          <a:prstGeom prst="rect">
+            <a:avLst/>
+          </a:prstGeom>
+          <a:noFill/>
+        </p:spPr>
+        <p:txBody>
+          <a:bodyPr wrap="square" rtlCol="0">
+            <a:spAutoFit/>
+          </a:bodyPr>
+          <a:lstStyle/>
+          <a:p>
+            <a:pPr algn="just"/>
+            <a:r>
+              <a:rPr lang="en-US" sz="2800" dirty="0">
+                <a:solidFill>
+                  <a:schemeClr val="bg1"/>
+                </a:solidFill>
+                <a:latin typeface="Arial" panose="020B0604020202020204" pitchFamily="34" charset="0"/>
+                <a:cs typeface="Arial" panose="020B0604020202020204" pitchFamily="34" charset="0"/>
+              </a:rPr>
+              <a:t>	</a:t>
+            </a:r>
+            <a:r>
+              <a:rPr lang="en-US" sz="2800" dirty="0">
+                <a:latin typeface="Arial" panose="020B0604020202020204" pitchFamily="34" charset="0"/>
+                <a:cs typeface="Arial" panose="020B0604020202020204" pitchFamily="34" charset="0"/>
+              </a:rPr>
+              <a:t>Household power usage is usually low, between 0.0 and 0.5. Green color shows that the household voltage is higher (0.3- 1.0), but usage is around 0.3 The purple color shows that the household uses high voltage and, during that time, uses high power as well. </a:t>
+            </a:r>
+          </a:p>
+          <a:p>
+            <a:endParaRPr lang="en-US" sz="2800" dirty="0"/>
+          </a:p>
+        </p:txBody>
+      </p:sp>
+      <p:sp>
+        <p:nvSpPr>
+          <p:cNvPr id="23" name="TextBox 22">
+            <a:extLst>
+              <a:ext uri="{FF2B5EF4-FFF2-40B4-BE49-F238E27FC236}">
+                <a16:creationId xmlns:a16="http://schemas.microsoft.com/office/drawing/2014/main" id="{509D64B6-8F21-20E2-F858-E3758BED5120}"/>
+              </a:ext>
+            </a:extLst>
+          </p:cNvPr>
+          <p:cNvSpPr txBox="1"/>
+          <p:nvPr/>
+        </p:nvSpPr>
+        <p:spPr>
+          <a:xfrm>
+            <a:off x="11752104" y="16175602"/>
+            <a:ext cx="9066174" cy="4832092"/>
+          </a:xfrm>
+          <a:prstGeom prst="rect">
+            <a:avLst/>
+          </a:prstGeom>
+          <a:noFill/>
+        </p:spPr>
+        <p:txBody>
+          <a:bodyPr wrap="square" rtlCol="0">
+            <a:spAutoFit/>
+          </a:bodyPr>
+          <a:lstStyle/>
+          <a:p>
+            <a:pPr algn="just"/>
+            <a:r>
+              <a:rPr lang="en-US" sz="2800" dirty="0">
+                <a:latin typeface="Arial" panose="020B0604020202020204" pitchFamily="34" charset="0"/>
+                <a:cs typeface="Arial" panose="020B0604020202020204" pitchFamily="34" charset="0"/>
+              </a:rPr>
+              <a:t>	Maximum K-distance is 0.4, min point is 5. In case, optimal labels has four categories which zero is 967, minus one is 20, one is 8, and two is 5. Household electricity consumption usage mostly belongs to zero, which is lower power usage. In some cases, when accidentally using high electricity around 4 to 4.5, the voltage is dropped to a normal level. About 20 is model-identified random usage. And, Optimal cluster is 4 for the Davis-Bouldin index, Silhouette score is 4 as well. </a:t>
+            </a:r>
+          </a:p>
+          <a:p>
+            <a:pPr algn="just"/>
+            <a:endParaRPr lang="en-US" sz="2800" dirty="0">
+              <a:latin typeface="Arial" panose="020B0604020202020204" pitchFamily="34" charset="0"/>
+              <a:cs typeface="Arial" panose="020B0604020202020204" pitchFamily="34" charset="0"/>
+            </a:endParaRPr>
+          </a:p>
+          <a:p>
+            <a:endParaRPr lang="en-US" sz="2800" dirty="0"/>
+          </a:p>
+        </p:txBody>
+      </p:sp>
+      <p:pic>
+        <p:nvPicPr>
+          <p:cNvPr id="29" name="Picture 28">
+            <a:extLst>
+              <a:ext uri="{FF2B5EF4-FFF2-40B4-BE49-F238E27FC236}">
+                <a16:creationId xmlns:a16="http://schemas.microsoft.com/office/drawing/2014/main" id="{7BD490EB-D80F-4587-D11D-2093DAFCB040}"/>
+              </a:ext>
+            </a:extLst>
+          </p:cNvPr>
+          <p:cNvPicPr>
+            <a:picLocks noChangeAspect="1"/>
+          </p:cNvPicPr>
+          <p:nvPr/>
+        </p:nvPicPr>
+        <p:blipFill>
+          <a:blip r:embed="rId8"/>
+          <a:stretch>
+            <a:fillRect/>
+          </a:stretch>
+        </p:blipFill>
+        <p:spPr>
+          <a:xfrm>
+            <a:off x="22537573" y="13868137"/>
+            <a:ext cx="7278967" cy="2437182"/>
+          </a:xfrm>
+          <a:prstGeom prst="rect">
+            <a:avLst/>
+          </a:prstGeom>
+        </p:spPr>
+      </p:pic>
+      <p:sp>
+        <p:nvSpPr>
+          <p:cNvPr id="31" name="TextBox 30">
+            <a:extLst>
+              <a:ext uri="{FF2B5EF4-FFF2-40B4-BE49-F238E27FC236}">
+                <a16:creationId xmlns:a16="http://schemas.microsoft.com/office/drawing/2014/main" id="{517407AA-11D8-D3DA-78BD-5483F3112CC0}"/>
+              </a:ext>
+            </a:extLst>
+          </p:cNvPr>
+          <p:cNvSpPr txBox="1"/>
+          <p:nvPr/>
+        </p:nvSpPr>
+        <p:spPr>
+          <a:xfrm>
+            <a:off x="29875873" y="13826809"/>
+            <a:ext cx="12677493" cy="5262979"/>
+          </a:xfrm>
+          <a:prstGeom prst="rect">
+            <a:avLst/>
+          </a:prstGeom>
+          <a:noFill/>
+        </p:spPr>
+        <p:txBody>
+          <a:bodyPr wrap="square" rtlCol="0">
+            <a:spAutoFit/>
+          </a:bodyPr>
+          <a:lstStyle/>
+          <a:p>
+            <a:pPr algn="just"/>
+            <a:r>
+              <a:rPr lang="en-US" sz="2800" dirty="0">
+                <a:latin typeface="Arial" panose="020B0604020202020204" pitchFamily="34" charset="0"/>
+                <a:cs typeface="Arial" panose="020B0604020202020204" pitchFamily="34" charset="0"/>
+              </a:rPr>
+              <a:t>	The best value is 2,1,2, which means household electricity past 2 hours usage represents next one hour. </a:t>
+            </a:r>
+          </a:p>
+          <a:p>
+            <a:pPr algn="just"/>
+            <a:r>
+              <a:rPr lang="en-US" sz="2800" dirty="0">
+                <a:latin typeface="Arial" panose="020B0604020202020204" pitchFamily="34" charset="0"/>
+                <a:cs typeface="Arial" panose="020B0604020202020204" pitchFamily="34" charset="0"/>
+              </a:rPr>
+              <a:t>Ljung result is 0.80, which means the model has identified a data pattern. And the household electricity consumption bit unexpectedly peaked during the evening so late-night decrease. Also, the histogram shows that the actual distribution is different from a normal distribution. </a:t>
+            </a:r>
+          </a:p>
+          <a:p>
+            <a:pPr algn="just"/>
+            <a:r>
+              <a:rPr lang="en-US" sz="2800" b="1" i="1" dirty="0">
+                <a:latin typeface="Arial" panose="020B0604020202020204" pitchFamily="34" charset="0"/>
+                <a:cs typeface="Arial" panose="020B0604020202020204" pitchFamily="34" charset="0"/>
+              </a:rPr>
+              <a:t>Forecast:</a:t>
+            </a:r>
+          </a:p>
+          <a:p>
+            <a:pPr algn="just"/>
+            <a:r>
+              <a:rPr lang="en-US" sz="2800" dirty="0">
+                <a:latin typeface="Arial" panose="020B0604020202020204" pitchFamily="34" charset="0"/>
+                <a:cs typeface="Arial" panose="020B0604020202020204" pitchFamily="34" charset="0"/>
+              </a:rPr>
+              <a:t>	I forecasted the next 120 hours of how household electricity will keep going in the next hours. Household power actual usage will be around 22 pm but it will decrease in the future. The model has explained 0.97 percent of the data.</a:t>
+            </a:r>
+          </a:p>
+          <a:p>
+            <a:pPr algn="just"/>
+            <a:endParaRPr lang="en-US" sz="2800" dirty="0">
+              <a:latin typeface="Arial" panose="020B0604020202020204" pitchFamily="34" charset="0"/>
+              <a:cs typeface="Arial" panose="020B0604020202020204" pitchFamily="34" charset="0"/>
+            </a:endParaRPr>
+          </a:p>
+          <a:p>
+            <a:endParaRPr lang="en-US" sz="2800" dirty="0"/>
+          </a:p>
+        </p:txBody>
+      </p:sp>
+      <p:sp>
+        <p:nvSpPr>
+          <p:cNvPr id="33" name="TextBox 32">
+            <a:extLst>
+              <a:ext uri="{FF2B5EF4-FFF2-40B4-BE49-F238E27FC236}">
+                <a16:creationId xmlns:a16="http://schemas.microsoft.com/office/drawing/2014/main" id="{A76F708C-0D2F-C1DB-4EF5-917D9917E1CA}"/>
+              </a:ext>
+            </a:extLst>
+          </p:cNvPr>
+          <p:cNvSpPr txBox="1"/>
+          <p:nvPr/>
+        </p:nvSpPr>
+        <p:spPr>
+          <a:xfrm>
+            <a:off x="29816539" y="18839624"/>
+            <a:ext cx="12677492" cy="7048083"/>
+          </a:xfrm>
+          <a:prstGeom prst="rect">
+            <a:avLst/>
+          </a:prstGeom>
+          <a:noFill/>
+        </p:spPr>
+        <p:txBody>
+          <a:bodyPr wrap="square" rtlCol="0">
+            <a:spAutoFit/>
+          </a:bodyPr>
+          <a:lstStyle/>
+          <a:p>
+            <a:pPr algn="just"/>
+            <a:r>
+              <a:rPr lang="en-US" sz="2800" dirty="0">
+                <a:solidFill>
+                  <a:schemeClr val="bg1"/>
+                </a:solidFill>
+                <a:latin typeface="Arial" panose="020B0604020202020204" pitchFamily="34" charset="0"/>
+                <a:cs typeface="Arial" panose="020B0604020202020204" pitchFamily="34" charset="0"/>
+              </a:rPr>
+              <a:t>	</a:t>
+            </a:r>
+            <a:r>
+              <a:rPr lang="en-US" sz="2800" dirty="0">
+                <a:latin typeface="Arial" panose="020B0604020202020204" pitchFamily="34" charset="0"/>
+                <a:cs typeface="Arial" panose="020B0604020202020204" pitchFamily="34" charset="0"/>
+              </a:rPr>
+              <a:t>The household use more electricity 2 am to 4 am, 10 am, 2 to 3 pm, 6 pm, 20 pm and 22 pm. Other hours it is less activity. </a:t>
+            </a:r>
+          </a:p>
+          <a:p>
+            <a:pPr algn="just"/>
+            <a:r>
+              <a:rPr lang="en-US" sz="2800" dirty="0">
+                <a:latin typeface="Arial" panose="020B0604020202020204" pitchFamily="34" charset="0"/>
+                <a:cs typeface="Arial" panose="020B0604020202020204" pitchFamily="34" charset="0"/>
+              </a:rPr>
+              <a:t>Triple Exponential </a:t>
+            </a:r>
+            <a:r>
+              <a:rPr lang="en-US" sz="2800" dirty="0" err="1">
+                <a:latin typeface="Arial" panose="020B0604020202020204" pitchFamily="34" charset="0"/>
+                <a:cs typeface="Arial" panose="020B0604020202020204" pitchFamily="34" charset="0"/>
+              </a:rPr>
+              <a:t>Smooting</a:t>
+            </a:r>
+            <a:r>
+              <a:rPr lang="en-US" sz="2800" dirty="0">
+                <a:latin typeface="Arial" panose="020B0604020202020204" pitchFamily="34" charset="0"/>
+                <a:cs typeface="Arial" panose="020B0604020202020204" pitchFamily="34" charset="0"/>
+              </a:rPr>
+              <a:t> result:</a:t>
+            </a:r>
+          </a:p>
+          <a:p>
+            <a:pPr algn="just"/>
+            <a:r>
+              <a:rPr lang="en-US" sz="2800" dirty="0">
+                <a:latin typeface="Arial" panose="020B0604020202020204" pitchFamily="34" charset="0"/>
+                <a:cs typeface="Arial" panose="020B0604020202020204" pitchFamily="34" charset="0"/>
+              </a:rPr>
+              <a:t>Gamma and Alpha show the best </a:t>
+            </a:r>
+            <a:r>
+              <a:rPr lang="en-US" sz="2800" dirty="0" err="1">
+                <a:latin typeface="Arial" panose="020B0604020202020204" pitchFamily="34" charset="0"/>
+                <a:cs typeface="Arial" panose="020B0604020202020204" pitchFamily="34" charset="0"/>
+              </a:rPr>
+              <a:t>predit</a:t>
+            </a:r>
+            <a:r>
+              <a:rPr lang="en-US" sz="2800" dirty="0">
+                <a:latin typeface="Arial" panose="020B0604020202020204" pitchFamily="34" charset="0"/>
+                <a:cs typeface="Arial" panose="020B0604020202020204" pitchFamily="34" charset="0"/>
+              </a:rPr>
+              <a:t> and they are error metric much more less which MSE is 0.03, MAE is 0.17, MAPE is 15.47. SARIMA model errors and triple smoothing errors are very close.</a:t>
+            </a:r>
+          </a:p>
+          <a:p>
+            <a:pPr algn="just"/>
+            <a:endParaRPr lang="en-US" sz="2800" dirty="0">
+              <a:latin typeface="Arial" panose="020B0604020202020204" pitchFamily="34" charset="0"/>
+              <a:cs typeface="Arial" panose="020B0604020202020204" pitchFamily="34" charset="0"/>
+            </a:endParaRPr>
+          </a:p>
+          <a:p>
+            <a:pPr algn="just"/>
+            <a:r>
+              <a:rPr lang="en-US" sz="2800" dirty="0">
+                <a:latin typeface="Arial" panose="020B0604020202020204" pitchFamily="34" charset="0"/>
+                <a:cs typeface="Arial" panose="020B0604020202020204" pitchFamily="34" charset="0"/>
+              </a:rPr>
+              <a:t>Exponential smoothing model results:</a:t>
+            </a:r>
+          </a:p>
+          <a:p>
+            <a:pPr algn="just"/>
+            <a:endParaRPr lang="mn-MN" sz="2800" dirty="0">
+              <a:latin typeface="Arial" panose="020B0604020202020204" pitchFamily="34" charset="0"/>
+              <a:cs typeface="Arial" panose="020B0604020202020204" pitchFamily="34" charset="0"/>
+            </a:endParaRPr>
+          </a:p>
+          <a:p>
+            <a:pPr algn="just"/>
+            <a:r>
+              <a:rPr lang="en-US" sz="2800" dirty="0">
+                <a:latin typeface="Arial" panose="020B0604020202020204" pitchFamily="34" charset="0"/>
+                <a:cs typeface="Arial" panose="020B0604020202020204" pitchFamily="34" charset="0"/>
+              </a:rPr>
+              <a:t>When compare actual data, addictive seasonality, multiplicate </a:t>
+            </a:r>
+            <a:r>
+              <a:rPr lang="en-US" sz="2800" dirty="0" err="1">
+                <a:latin typeface="Arial" panose="020B0604020202020204" pitchFamily="34" charset="0"/>
+                <a:cs typeface="Arial" panose="020B0604020202020204" pitchFamily="34" charset="0"/>
+              </a:rPr>
+              <a:t>seasonalty</a:t>
+            </a:r>
+            <a:r>
+              <a:rPr lang="en-US" sz="2800" dirty="0">
+                <a:latin typeface="Arial" panose="020B0604020202020204" pitchFamily="34" charset="0"/>
+                <a:cs typeface="Arial" panose="020B0604020202020204" pitchFamily="34" charset="0"/>
+              </a:rPr>
+              <a:t>, track are close but different from actual data, in other words, exponential smoothing model has been predicted between 1.5 to 4.5 kilowatt but household </a:t>
+            </a:r>
+            <a:r>
+              <a:rPr lang="en-US" sz="2800" dirty="0" err="1">
+                <a:latin typeface="Arial" panose="020B0604020202020204" pitchFamily="34" charset="0"/>
+                <a:cs typeface="Arial" panose="020B0604020202020204" pitchFamily="34" charset="0"/>
+              </a:rPr>
+              <a:t>electicity</a:t>
+            </a:r>
+            <a:r>
+              <a:rPr lang="en-US" sz="2800" dirty="0">
+                <a:latin typeface="Arial" panose="020B0604020202020204" pitchFamily="34" charset="0"/>
+                <a:cs typeface="Arial" panose="020B0604020202020204" pitchFamily="34" charset="0"/>
+              </a:rPr>
+              <a:t> spikes between to 7.9 kilowatt. </a:t>
+            </a:r>
+          </a:p>
+          <a:p>
+            <a:pPr algn="just"/>
+            <a:endParaRPr lang="en-US" sz="3200" dirty="0">
+              <a:latin typeface="Arial" panose="020B0604020202020204" pitchFamily="34" charset="0"/>
+              <a:cs typeface="Arial" panose="020B0604020202020204" pitchFamily="34" charset="0"/>
+            </a:endParaRPr>
+          </a:p>
+          <a:p>
+            <a:pPr algn="just"/>
+            <a:endParaRPr lang="en-US" sz="2800" dirty="0">
+              <a:latin typeface="Arial" panose="020B0604020202020204" pitchFamily="34" charset="0"/>
+              <a:cs typeface="Arial" panose="020B0604020202020204" pitchFamily="34" charset="0"/>
+            </a:endParaRPr>
+          </a:p>
+          <a:p>
+            <a:endParaRPr lang="en-US" sz="2800" dirty="0"/>
+          </a:p>
+        </p:txBody>
+      </p:sp>
+      <p:pic>
+        <p:nvPicPr>
+          <p:cNvPr id="5" name="Picture 4">
+            <a:extLst>
+              <a:ext uri="{FF2B5EF4-FFF2-40B4-BE49-F238E27FC236}">
+                <a16:creationId xmlns:a16="http://schemas.microsoft.com/office/drawing/2014/main" id="{B1FB7E00-DDA5-86BA-5307-0848600550C4}"/>
+              </a:ext>
+            </a:extLst>
+          </p:cNvPr>
+          <p:cNvPicPr>
+            <a:picLocks noChangeAspect="1"/>
+          </p:cNvPicPr>
+          <p:nvPr/>
+        </p:nvPicPr>
+        <p:blipFill>
+          <a:blip r:embed="rId9"/>
+          <a:stretch>
+            <a:fillRect/>
+          </a:stretch>
+        </p:blipFill>
+        <p:spPr>
+          <a:xfrm>
+            <a:off x="6576725" y="6549736"/>
+            <a:ext cx="5054363" cy="3899884"/>
+          </a:xfrm>
+          <a:prstGeom prst="rect">
+            <a:avLst/>
+          </a:prstGeom>
+        </p:spPr>
+      </p:pic>
+      <p:pic>
+        <p:nvPicPr>
+          <p:cNvPr id="12" name="Picture 11">
+            <a:extLst>
+              <a:ext uri="{FF2B5EF4-FFF2-40B4-BE49-F238E27FC236}">
+                <a16:creationId xmlns:a16="http://schemas.microsoft.com/office/drawing/2014/main" id="{EDA19E91-6BC2-B8B0-7B4E-B182A0BDD54E}"/>
+              </a:ext>
+            </a:extLst>
+          </p:cNvPr>
+          <p:cNvPicPr>
+            <a:picLocks noChangeAspect="1"/>
+          </p:cNvPicPr>
+          <p:nvPr/>
+        </p:nvPicPr>
+        <p:blipFill>
+          <a:blip r:embed="rId10"/>
+          <a:stretch>
+            <a:fillRect/>
+          </a:stretch>
+        </p:blipFill>
+        <p:spPr>
+          <a:xfrm>
+            <a:off x="1217678" y="21893198"/>
+            <a:ext cx="10630376" cy="3636999"/>
+          </a:xfrm>
+          <a:prstGeom prst="rect">
+            <a:avLst/>
+          </a:prstGeom>
+        </p:spPr>
+      </p:pic>
+      <p:sp>
+        <p:nvSpPr>
+          <p:cNvPr id="25" name="TextBox 24">
+            <a:extLst>
+              <a:ext uri="{FF2B5EF4-FFF2-40B4-BE49-F238E27FC236}">
+                <a16:creationId xmlns:a16="http://schemas.microsoft.com/office/drawing/2014/main" id="{E3F8CBD9-C668-1102-C5E6-CD5919B57FF2}"/>
+              </a:ext>
+            </a:extLst>
+          </p:cNvPr>
+          <p:cNvSpPr txBox="1"/>
+          <p:nvPr/>
+        </p:nvSpPr>
+        <p:spPr>
+          <a:xfrm>
+            <a:off x="11903205" y="21007694"/>
+            <a:ext cx="9207719" cy="3970318"/>
+          </a:xfrm>
+          <a:prstGeom prst="rect">
+            <a:avLst/>
+          </a:prstGeom>
+          <a:noFill/>
+        </p:spPr>
+        <p:txBody>
+          <a:bodyPr wrap="square" rtlCol="0">
+            <a:spAutoFit/>
+          </a:bodyPr>
+          <a:lstStyle/>
+          <a:p>
+            <a:pPr algn="just"/>
+            <a:r>
+              <a:rPr lang="en-US" sz="2800" dirty="0">
+                <a:solidFill>
+                  <a:schemeClr val="bg1"/>
+                </a:solidFill>
+                <a:latin typeface="Arial" panose="020B0604020202020204" pitchFamily="34" charset="0"/>
+                <a:cs typeface="Arial" panose="020B0604020202020204" pitchFamily="34" charset="0"/>
+              </a:rPr>
+              <a:t>	</a:t>
+            </a:r>
+            <a:r>
+              <a:rPr lang="en-US" sz="2800" dirty="0">
+                <a:latin typeface="Arial" panose="020B0604020202020204" pitchFamily="34" charset="0"/>
+                <a:cs typeface="Arial" panose="020B0604020202020204" pitchFamily="34" charset="0"/>
+              </a:rPr>
+              <a:t>Graph shows that massive power usage more than others but centroid recognized around 1.8. And mostly power usage around 0.3-0.7 which household power usage usually low, in other words, 70 percentage powers is low, 30 percent shows that normal usage and suddenly peak usage. Davis-Boulding optimal cluster is 4, Silhouette score is 4 as well.</a:t>
+            </a:r>
+          </a:p>
+          <a:p>
+            <a:pPr algn="just"/>
+            <a:endParaRPr lang="en-US" sz="2800" dirty="0">
+              <a:latin typeface="Arial" panose="020B0604020202020204" pitchFamily="34" charset="0"/>
+              <a:cs typeface="Arial" panose="020B0604020202020204" pitchFamily="34" charset="0"/>
+            </a:endParaRPr>
+          </a:p>
+          <a:p>
+            <a:endParaRPr lang="en-US" sz="2800" dirty="0"/>
+          </a:p>
+        </p:txBody>
+      </p:sp>
+      <p:pic>
+        <p:nvPicPr>
+          <p:cNvPr id="7" name="Picture 6">
+            <a:extLst>
+              <a:ext uri="{FF2B5EF4-FFF2-40B4-BE49-F238E27FC236}">
+                <a16:creationId xmlns:a16="http://schemas.microsoft.com/office/drawing/2014/main" id="{C66246BD-756B-35E6-8B00-069BFBCE30EF}"/>
+              </a:ext>
+            </a:extLst>
+          </p:cNvPr>
+          <p:cNvPicPr>
+            <a:picLocks noChangeAspect="1"/>
+          </p:cNvPicPr>
+          <p:nvPr/>
+        </p:nvPicPr>
+        <p:blipFill>
+          <a:blip r:embed="rId11"/>
+          <a:stretch>
+            <a:fillRect/>
+          </a:stretch>
+        </p:blipFill>
+        <p:spPr>
+          <a:xfrm>
+            <a:off x="22537573" y="16458298"/>
+            <a:ext cx="7278966" cy="2437182"/>
+          </a:xfrm>
+          <a:prstGeom prst="rect">
+            <a:avLst/>
+          </a:prstGeom>
+        </p:spPr>
+      </p:pic>
     </p:spTree>
     <p:extLst>
       <p:ext uri="{BB962C8B-B14F-4D97-AF65-F5344CB8AC3E}">
@@ -4182,4 +5643,299 @@
     </a:ext>
   </a:extLst>
 </a:theme>
+</file>
+
+<file path=ppt/theme/theme2.xml><?xml version="1.0" encoding="utf-8"?>
+<a:theme xmlns:a="http://schemas.openxmlformats.org/drawingml/2006/main" name="Office Theme">
+  <a:themeElements>
+    <a:clrScheme name="Office">
+      <a:dk1>
+        <a:sysClr val="windowText" lastClr="000000"/>
+      </a:dk1>
+      <a:lt1>
+        <a:sysClr val="window" lastClr="FFFFFF"/>
+      </a:lt1>
+      <a:dk2>
+        <a:srgbClr val="44546A"/>
+      </a:dk2>
+      <a:lt2>
+        <a:srgbClr val="E7E6E6"/>
+      </a:lt2>
+      <a:accent1>
+        <a:srgbClr val="4472C4"/>
+      </a:accent1>
+      <a:accent2>
+        <a:srgbClr val="ED7D31"/>
+      </a:accent2>
+      <a:accent3>
+        <a:srgbClr val="A5A5A5"/>
+      </a:accent3>
+      <a:accent4>
+        <a:srgbClr val="FFC000"/>
+      </a:accent4>
+      <a:accent5>
+        <a:srgbClr val="5B9BD5"/>
+      </a:accent5>
+      <a:accent6>
+        <a:srgbClr val="70AD47"/>
+      </a:accent6>
+      <a:hlink>
+        <a:srgbClr val="0563C1"/>
+      </a:hlink>
+      <a:folHlink>
+        <a:srgbClr val="954F72"/>
+      </a:folHlink>
+    </a:clrScheme>
+    <a:fontScheme name="Office">
+      <a:majorFont>
+        <a:latin typeface="Calibri Light" panose="020F0302020204030204"/>
+        <a:ea typeface=""/>
+        <a:cs typeface=""/>
+        <a:font script="Jpan" typeface="游ゴシック Light"/>
+        <a:font script="Hang" typeface="맑은 고딕"/>
+        <a:font script="Hans" typeface="等线 Light"/>
+        <a:font script="Hant" typeface="新細明體"/>
+        <a:font script="Arab" typeface="Times New Roman"/>
+        <a:font script="Hebr" typeface="Times New Roman"/>
+        <a:font script="Thai" typeface="Angsana New"/>
+        <a:font script="Ethi" typeface="Nyala"/>
+        <a:font script="Beng" typeface="Vrinda"/>
+        <a:font script="Gujr" typeface="Shruti"/>
+        <a:font script="Khmr" typeface="MoolBoran"/>
+        <a:font script="Knda" typeface="Tunga"/>
+        <a:font script="Guru" typeface="Raavi"/>
+        <a:font script="Cans" typeface="Euphemia"/>
+        <a:font script="Cher" typeface="Plantagenet Cherokee"/>
+        <a:font script="Yiii" typeface="Microsoft Yi Baiti"/>
+        <a:font script="Tibt" typeface="Microsoft Himalaya"/>
+        <a:font script="Thaa" typeface="MV Boli"/>
+        <a:font script="Deva" typeface="Mangal"/>
+        <a:font script="Telu" typeface="Gautami"/>
+        <a:font script="Taml" typeface="Latha"/>
+        <a:font script="Syrc" typeface="Estrangelo Edessa"/>
+        <a:font script="Orya" typeface="Kalinga"/>
+        <a:font script="Mlym" typeface="Kartika"/>
+        <a:font script="Laoo" typeface="DokChampa"/>
+        <a:font script="Sinh" typeface="Iskoola Pota"/>
+        <a:font script="Mong" typeface="Mongolian Baiti"/>
+        <a:font script="Viet" typeface="Times New Roman"/>
+        <a:font script="Uigh" typeface="Microsoft Uighur"/>
+        <a:font script="Geor" typeface="Sylfaen"/>
+        <a:font script="Armn" typeface="Arial"/>
+        <a:font script="Bugi" typeface="Leelawadee UI"/>
+        <a:font script="Bopo" typeface="Microsoft JhengHei"/>
+        <a:font script="Java" typeface="Javanese Text"/>
+        <a:font script="Lisu" typeface="Segoe UI"/>
+        <a:font script="Mymr" typeface="Myanmar Text"/>
+        <a:font script="Nkoo" typeface="Ebrima"/>
+        <a:font script="Olck" typeface="Nirmala UI"/>
+        <a:font script="Osma" typeface="Ebrima"/>
+        <a:font script="Phag" typeface="Phagspa"/>
+        <a:font script="Syrn" typeface="Estrangelo Edessa"/>
+        <a:font script="Syrj" typeface="Estrangelo Edessa"/>
+        <a:font script="Syre" typeface="Estrangelo Edessa"/>
+        <a:font script="Sora" typeface="Nirmala UI"/>
+        <a:font script="Tale" typeface="Microsoft Tai Le"/>
+        <a:font script="Talu" typeface="Microsoft New Tai Lue"/>
+        <a:font script="Tfng" typeface="Ebrima"/>
+      </a:majorFont>
+      <a:minorFont>
+        <a:latin typeface="Calibri" panose="020F0502020204030204"/>
+        <a:ea typeface=""/>
+        <a:cs typeface=""/>
+        <a:font script="Jpan" typeface="游ゴシック"/>
+        <a:font script="Hang" typeface="맑은 고딕"/>
+        <a:font script="Hans" typeface="等线"/>
+        <a:font script="Hant" typeface="新細明體"/>
+        <a:font script="Arab" typeface="Arial"/>
+        <a:font script="Hebr" typeface="Arial"/>
+        <a:font script="Thai" typeface="Cordia New"/>
+        <a:font script="Ethi" typeface="Nyala"/>
+        <a:font script="Beng" typeface="Vrinda"/>
+        <a:font script="Gujr" typeface="Shruti"/>
+        <a:font script="Khmr" typeface="DaunPenh"/>
+        <a:font script="Knda" typeface="Tunga"/>
+        <a:font script="Guru" typeface="Raavi"/>
+        <a:font script="Cans" typeface="Euphemia"/>
+        <a:font script="Cher" typeface="Plantagenet Cherokee"/>
+        <a:font script="Yiii" typeface="Microsoft Yi Baiti"/>
+        <a:font script="Tibt" typeface="Microsoft Himalaya"/>
+        <a:font script="Thaa" typeface="MV Boli"/>
+        <a:font script="Deva" typeface="Mangal"/>
+        <a:font script="Telu" typeface="Gautami"/>
+        <a:font script="Taml" typeface="Latha"/>
+        <a:font script="Syrc" typeface="Estrangelo Edessa"/>
+        <a:font script="Orya" typeface="Kalinga"/>
+        <a:font script="Mlym" typeface="Kartika"/>
+        <a:font script="Laoo" typeface="DokChampa"/>
+        <a:font script="Sinh" typeface="Iskoola Pota"/>
+        <a:font script="Mong" typeface="Mongolian Baiti"/>
+        <a:font script="Viet" typeface="Arial"/>
+        <a:font script="Uigh" typeface="Microsoft Uighur"/>
+        <a:font script="Geor" typeface="Sylfaen"/>
+        <a:font script="Armn" typeface="Arial"/>
+        <a:font script="Bugi" typeface="Leelawadee UI"/>
+        <a:font script="Bopo" typeface="Microsoft JhengHei"/>
+        <a:font script="Java" typeface="Javanese Text"/>
+        <a:font script="Lisu" typeface="Segoe UI"/>
+        <a:font script="Mymr" typeface="Myanmar Text"/>
+        <a:font script="Nkoo" typeface="Ebrima"/>
+        <a:font script="Olck" typeface="Nirmala UI"/>
+        <a:font script="Osma" typeface="Ebrima"/>
+        <a:font script="Phag" typeface="Phagspa"/>
+        <a:font script="Syrn" typeface="Estrangelo Edessa"/>
+        <a:font script="Syrj" typeface="Estrangelo Edessa"/>
+        <a:font script="Syre" typeface="Estrangelo Edessa"/>
+        <a:font script="Sora" typeface="Nirmala UI"/>
+        <a:font script="Tale" typeface="Microsoft Tai Le"/>
+        <a:font script="Talu" typeface="Microsoft New Tai Lue"/>
+        <a:font script="Tfng" typeface="Ebrima"/>
+      </a:minorFont>
+    </a:fontScheme>
+    <a:fmtScheme name="Office">
+      <a:fillStyleLst>
+        <a:solidFill>
+          <a:schemeClr val="phClr"/>
+        </a:solidFill>
+        <a:gradFill rotWithShape="1">
+          <a:gsLst>
+            <a:gs pos="0">
+              <a:schemeClr val="phClr">
+                <a:lumMod val="110000"/>
+                <a:satMod val="105000"/>
+                <a:tint val="67000"/>
+              </a:schemeClr>
+            </a:gs>
+            <a:gs pos="50000">
+              <a:schemeClr val="phClr">
+                <a:lumMod val="105000"/>
+                <a:satMod val="103000"/>
+                <a:tint val="73000"/>
+              </a:schemeClr>
+            </a:gs>
+            <a:gs pos="100000">
+              <a:schemeClr val="phClr">
+                <a:lumMod val="105000"/>
+                <a:satMod val="109000"/>
+                <a:tint val="81000"/>
+              </a:schemeClr>
+            </a:gs>
+          </a:gsLst>
+          <a:lin ang="5400000" scaled="0"/>
+        </a:gradFill>
+        <a:gradFill rotWithShape="1">
+          <a:gsLst>
+            <a:gs pos="0">
+              <a:schemeClr val="phClr">
+                <a:satMod val="103000"/>
+                <a:lumMod val="102000"/>
+                <a:tint val="94000"/>
+              </a:schemeClr>
+            </a:gs>
+            <a:gs pos="50000">
+              <a:schemeClr val="phClr">
+                <a:satMod val="110000"/>
+                <a:lumMod val="100000"/>
+                <a:shade val="100000"/>
+              </a:schemeClr>
+            </a:gs>
+            <a:gs pos="100000">
+              <a:schemeClr val="phClr">
+                <a:lumMod val="99000"/>
+                <a:satMod val="120000"/>
+                <a:shade val="78000"/>
+              </a:schemeClr>
+            </a:gs>
+          </a:gsLst>
+          <a:lin ang="5400000" scaled="0"/>
+        </a:gradFill>
+      </a:fillStyleLst>
+      <a:lnStyleLst>
+        <a:ln w="6350" cap="flat" cmpd="sng" algn="ctr">
+          <a:solidFill>
+            <a:schemeClr val="phClr"/>
+          </a:solidFill>
+          <a:prstDash val="solid"/>
+          <a:miter lim="800000"/>
+        </a:ln>
+        <a:ln w="12700" cap="flat" cmpd="sng" algn="ctr">
+          <a:solidFill>
+            <a:schemeClr val="phClr"/>
+          </a:solidFill>
+          <a:prstDash val="solid"/>
+          <a:miter lim="800000"/>
+        </a:ln>
+        <a:ln w="19050" cap="flat" cmpd="sng" algn="ctr">
+          <a:solidFill>
+            <a:schemeClr val="phClr"/>
+          </a:solidFill>
+          <a:prstDash val="solid"/>
+          <a:miter lim="800000"/>
+        </a:ln>
+      </a:lnStyleLst>
+      <a:effectStyleLst>
+        <a:effectStyle>
+          <a:effectLst/>
+        </a:effectStyle>
+        <a:effectStyle>
+          <a:effectLst/>
+        </a:effectStyle>
+        <a:effectStyle>
+          <a:effectLst>
+            <a:outerShdw blurRad="57150" dist="19050" dir="5400000" algn="ctr" rotWithShape="0">
+              <a:srgbClr val="000000">
+                <a:alpha val="63000"/>
+              </a:srgbClr>
+            </a:outerShdw>
+          </a:effectLst>
+        </a:effectStyle>
+      </a:effectStyleLst>
+      <a:bgFillStyleLst>
+        <a:solidFill>
+          <a:schemeClr val="phClr"/>
+        </a:solidFill>
+        <a:solidFill>
+          <a:schemeClr val="phClr">
+            <a:tint val="95000"/>
+            <a:satMod val="170000"/>
+          </a:schemeClr>
+        </a:solidFill>
+        <a:gradFill rotWithShape="1">
+          <a:gsLst>
+            <a:gs pos="0">
+              <a:schemeClr val="phClr">
+                <a:tint val="93000"/>
+                <a:satMod val="150000"/>
+                <a:shade val="98000"/>
+                <a:lumMod val="102000"/>
+              </a:schemeClr>
+            </a:gs>
+            <a:gs pos="50000">
+              <a:schemeClr val="phClr">
+                <a:tint val="98000"/>
+                <a:satMod val="130000"/>
+                <a:shade val="90000"/>
+                <a:lumMod val="103000"/>
+              </a:schemeClr>
+            </a:gs>
+            <a:gs pos="100000">
+              <a:schemeClr val="phClr">
+                <a:shade val="63000"/>
+                <a:satMod val="120000"/>
+              </a:schemeClr>
+            </a:gs>
+          </a:gsLst>
+          <a:lin ang="5400000" scaled="0"/>
+        </a:gradFill>
+      </a:bgFillStyleLst>
+    </a:fmtScheme>
+  </a:themeElements>
+  <a:objectDefaults/>
+  <a:extraClrSchemeLst/>
+  <a:extLst>
+    <a:ext uri="{05A4C25C-085E-4340-85A3-A5531E510DB2}">
+      <thm15:themeFamily xmlns:thm15="http://schemas.microsoft.com/office/thememl/2012/main" name="Office Theme" id="{62F939B6-93AF-4DB8-9C6B-D6C7DFDC589F}" vid="{4A3C46E8-61CC-4603-A589-7422A47A8E4A}"/>
+    </a:ext>
+  </a:extLst>
+</a:theme>
 </file>
</xml_diff>